<commit_message>
doc: met le diaporama à jour avec la charge du requin
Co-Authored-By: Claude Opus 5.5 <noreply@anthropic.com>
</commit_message>
<xml_diff>
--- a/soutenance/thon-sur-thon.pptx
+++ b/soutenance/thon-sur-thon.pptx
@@ -13,12 +13,9 @@
     <p:sldId id="261" r:id="rId7"/>
     <p:sldId id="262" r:id="rId8"/>
     <p:sldId id="263" r:id="rId9"/>
-    <p:sldId id="264" r:id="rId10"/>
-    <p:sldId id="265" r:id="rId11"/>
-    <p:sldId id="266" r:id="rId12"/>
   </p:sldIdLst>
   <p:notesMasterIdLst>
-    <p:notesMasterId r:id="rId13"/>
+    <p:notesMasterId r:id="rId10"/>
   </p:notesMasterIdLst>
   <p:sldSz cx="12192000" cy="6858000"/>
   <p:notesSz cx="6858000" cy="12192000"/>
@@ -117,35 +114,28 @@
   <p:extLst>
     <p:ext uri="{521415D9-36F7-43E2-AB2F-B90AF26B5E84}">
       <p14:sectionLst xmlns:p14="http://schemas.microsoft.com/office/powerpoint/2010/main">
-        <p14:section name="Titre" id="{74c1dcb8-ade8-da0b-cdda-47199724856a}">
+        <p14:section name="Titre" id="{aab20f0c-a0ed-4eaf-c334-41abd45fd269}">
           <p14:sldIdLst>
             <p14:sldId id="256"/>
           </p14:sldIdLst>
         </p14:section>
-        <p14:section name="Modèle" id="{339dcc70-ce3a-ecae-a324-575c6c26167b}">
+        <p14:section name="Modèle" id="{6f0cdd59-02c2-84e6-9743-1ce97dbfca94}">
           <p14:sldIdLst>
             <p14:sldId id="257"/>
             <p14:sldId id="258"/>
             <p14:sldId id="259"/>
             <p14:sldId id="260"/>
             <p14:sldId id="261"/>
+          </p14:sldIdLst>
+        </p14:section>
+        <p14:section name="Démonstration" id="{72f45ab6-e087-9299-ec55-237a1247780d}">
+          <p14:sldIdLst>
             <p14:sldId id="262"/>
           </p14:sldIdLst>
         </p14:section>
-        <p14:section name="Démonstration" id="{467fc433-f3ce-afa3-1a4f-0365c99fc5a5}">
+        <p14:section name="Bilan" id="{3c47bb1a-7800-684a-6633-56865118f744}">
           <p14:sldIdLst>
             <p14:sldId id="263"/>
-          </p14:sldIdLst>
-        </p14:section>
-        <p14:section name="Bilan" id="{eedf1596-d4ef-8755-2fea-dd61fa27d598}">
-          <p14:sldIdLst>
-            <p14:sldId id="264"/>
-            <p14:sldId id="265"/>
-          </p14:sldIdLst>
-        </p14:section>
-        <p14:section name="Annexe" id="{47f8b1a4-241f-9973-e49d-96ccc940e4aa}">
-          <p14:sldIdLst>
-            <p14:sldId id="266"/>
           </p14:sldIdLst>
         </p14:section>
       </p14:sectionLst>
@@ -594,185 +584,6 @@
 </p:notes>
 </file>
 
-<file path=ppt/notesSlides/notesSlide10.xml><?xml version="1.0" encoding="utf-8"?>
-<p:notes xmlns:a="http://schemas.openxmlformats.org/drawingml/2006/main" xmlns:r="http://schemas.openxmlformats.org/officeDocument/2006/relationships" xmlns:p="http://schemas.openxmlformats.org/presentationml/2006/main">
-  <p:cSld>
-    <p:spTree>
-      <p:nvGrpSpPr>
-        <p:cNvPr id="1" name=""/>
-        <p:cNvGrpSpPr/>
-        <p:nvPr/>
-      </p:nvGrpSpPr>
-      <p:grpSpPr>
-        <a:xfrm>
-          <a:off x="0" y="0"/>
-          <a:ext cx="0" cy="0"/>
-          <a:chOff x="0" y="0"/>
-          <a:chExt cx="0" cy="0"/>
-        </a:xfrm>
-      </p:grpSpPr>
-      <p:sp>
-        <p:nvSpPr>
-          <p:cNvPr id="2" name="Slide Image Placeholder 1"/>
-          <p:cNvSpPr>
-            <a:spLocks noGrp="1" noRot="1" noChangeAspect="1"/>
-          </p:cNvSpPr>
-          <p:nvPr>
-            <p:ph type="sldImg"/>
-          </p:nvPr>
-        </p:nvSpPr>
-        <p:spPr/>
-      </p:sp>
-      <p:sp>
-        <p:nvSpPr>
-          <p:cNvPr id="3" name="Notes Placeholder 2"/>
-          <p:cNvSpPr>
-            <a:spLocks noGrp="1"/>
-          </p:cNvSpPr>
-          <p:nvPr>
-            <p:ph type="body" idx="1"/>
-          </p:nvPr>
-        </p:nvSpPr>
-        <p:spPr/>
-        <p:txBody>
-          <a:bodyPr/>
-          <a:lstStyle/>
-          <a:p>
-            <a:r>
-              <a:rPr lang="en-US" dirty="0"/>
-              <a:t>Consigne : présenter les perspectives.
-Source : « Idées pour plus tard » de doc/versions.md.</a:t>
-            </a:r>
-            <a:endParaRPr lang="en-US" dirty="0"/>
-          </a:p>
-        </p:txBody>
-      </p:sp>
-      <p:sp>
-        <p:nvSpPr>
-          <p:cNvPr id="4" name="Slide Number Placeholder 3"/>
-          <p:cNvSpPr>
-            <a:spLocks noGrp="1"/>
-          </p:cNvSpPr>
-          <p:nvPr>
-            <p:ph type="sldNum" sz="quarter" idx="10"/>
-          </p:nvPr>
-        </p:nvSpPr>
-        <p:spPr/>
-        <p:txBody>
-          <a:bodyPr/>
-          <a:lstStyle/>
-          <a:p>
-            <a:fld id="{F7021451-1387-4CA6-816F-3879F97B5CBC}" type="slidenum">
-              <a:rPr lang="en-US"/>
-              <a:t>10</a:t>
-            </a:fld>
-            <a:endParaRPr lang="en-US"/>
-          </a:p>
-        </p:txBody>
-      </p:sp>
-    </p:spTree>
-    <p:extLst>
-      <p:ext uri="{BB962C8B-B14F-4D97-AF65-F5344CB8AC3E}">
-        <p14:creationId xmlns:p14="http://schemas.microsoft.com/office/powerpoint/2010/main" val="1024086991"/>
-      </p:ext>
-    </p:extLst>
-  </p:cSld>
-  <p:clrMapOvr>
-    <a:masterClrMapping/>
-  </p:clrMapOvr>
-</p:notes>
-</file>
-
-<file path=ppt/notesSlides/notesSlide11.xml><?xml version="1.0" encoding="utf-8"?>
-<p:notes xmlns:a="http://schemas.openxmlformats.org/drawingml/2006/main" xmlns:r="http://schemas.openxmlformats.org/officeDocument/2006/relationships" xmlns:p="http://schemas.openxmlformats.org/presentationml/2006/main">
-  <p:cSld>
-    <p:spTree>
-      <p:nvGrpSpPr>
-        <p:cNvPr id="1" name=""/>
-        <p:cNvGrpSpPr/>
-        <p:nvPr/>
-      </p:nvGrpSpPr>
-      <p:grpSpPr>
-        <a:xfrm>
-          <a:off x="0" y="0"/>
-          <a:ext cx="0" cy="0"/>
-          <a:chOff x="0" y="0"/>
-          <a:chExt cx="0" cy="0"/>
-        </a:xfrm>
-      </p:grpSpPr>
-      <p:sp>
-        <p:nvSpPr>
-          <p:cNvPr id="2" name="Slide Image Placeholder 1"/>
-          <p:cNvSpPr>
-            <a:spLocks noGrp="1" noRot="1" noChangeAspect="1"/>
-          </p:cNvSpPr>
-          <p:nvPr>
-            <p:ph type="sldImg"/>
-          </p:nvPr>
-        </p:nvSpPr>
-        <p:spPr/>
-      </p:sp>
-      <p:sp>
-        <p:nvSpPr>
-          <p:cNvPr id="3" name="Notes Placeholder 2"/>
-          <p:cNvSpPr>
-            <a:spLocks noGrp="1"/>
-          </p:cNvSpPr>
-          <p:nvPr>
-            <p:ph type="body" idx="1"/>
-          </p:nvPr>
-        </p:nvSpPr>
-        <p:spPr/>
-        <p:txBody>
-          <a:bodyPr/>
-          <a:lstStyle/>
-          <a:p>
-            <a:r>
-              <a:rPr lang="en-US" dirty="0"/>
-              <a:t>Hors des 4 minutes : à garder pour les questions.
-Source : godot/aquarium/aquarium.gd, fonction _physics_process.
-Schéma : soutenance/schemas/pas-de-simulation.excalidraw (à rouvrir dans Excalidraw pour le corriger).</a:t>
-            </a:r>
-            <a:endParaRPr lang="en-US" dirty="0"/>
-          </a:p>
-        </p:txBody>
-      </p:sp>
-      <p:sp>
-        <p:nvSpPr>
-          <p:cNvPr id="4" name="Slide Number Placeholder 3"/>
-          <p:cNvSpPr>
-            <a:spLocks noGrp="1"/>
-          </p:cNvSpPr>
-          <p:nvPr>
-            <p:ph type="sldNum" sz="quarter" idx="10"/>
-          </p:nvPr>
-        </p:nvSpPr>
-        <p:spPr/>
-        <p:txBody>
-          <a:bodyPr/>
-          <a:lstStyle/>
-          <a:p>
-            <a:fld id="{F7021451-1387-4CA6-816F-3879F97B5CBC}" type="slidenum">
-              <a:rPr lang="en-US"/>
-              <a:t>11</a:t>
-            </a:fld>
-            <a:endParaRPr lang="en-US"/>
-          </a:p>
-        </p:txBody>
-      </p:sp>
-    </p:spTree>
-    <p:extLst>
-      <p:ext uri="{BB962C8B-B14F-4D97-AF65-F5344CB8AC3E}">
-        <p14:creationId xmlns:p14="http://schemas.microsoft.com/office/powerpoint/2010/main" val="1024086991"/>
-      </p:ext>
-    </p:extLst>
-  </p:cSld>
-  <p:clrMapOvr>
-    <a:masterClrMapping/>
-  </p:clrMapOvr>
-</p:notes>
-</file>
-
 <file path=ppt/notesSlides/notesSlide2.xml><?xml version="1.0" encoding="utf-8"?>
 <p:notes xmlns:a="http://schemas.openxmlformats.org/drawingml/2006/main" xmlns:r="http://schemas.openxmlformats.org/officeDocument/2006/relationships" xmlns:p="http://schemas.openxmlformats.org/presentationml/2006/main">
   <p:cSld>
@@ -1269,9 +1080,7 @@
           <a:p>
             <a:r>
               <a:rPr lang="en-US" dirty="0"/>
-              <a:t>Consigne : état(s) initial(aux).
-Source : godot/aquarium/aquarium.gd (_creer_banc, _creer_requin, _position_au_hasard), godot/thon/thon.gd (_ready).
-Schéma : soutenance/schemas/etat-initial.excalidraw (à rouvrir dans Excalidraw pour le corriger).</a:t>
+              <a:t>Consigne : exécuter la simulation, en direct ou en vidéo pré-enregistrée. Ici on passe sur le jeu.</a:t>
             </a:r>
             <a:endParaRPr lang="en-US" dirty="0"/>
           </a:p>
@@ -1359,9 +1168,8 @@
           <a:p>
             <a:r>
               <a:rPr lang="en-US" dirty="0"/>
-              <a:t>Consigne : exécuter la simulation, en direct ou en vidéo pré-enregistrée.
-Boutons « Plonger », « Valeurs par défaut », « Relancer » et curseurs « Vision », « Alignement » : godot/accueil/accueil.tscn, godot/interface/interface.gd.
-Effets annoncés : mesurés sans fenêtre (soutenance/mesures/resultats.txt, arguments rv=4 et pa=0). Déroulé proposé par Claude, à répéter à l'écran avant de le garder.</a:t>
+              <a:t>Consigne : présenter les perspectives.
+Source : « Idées pour plus tard » de doc/versions.md.</a:t>
             </a:r>
             <a:endParaRPr lang="en-US" dirty="0"/>
           </a:p>
@@ -1385,97 +1193,6 @@
             <a:fld id="{F7021451-1387-4CA6-816F-3879F97B5CBC}" type="slidenum">
               <a:rPr lang="en-US"/>
               <a:t>8</a:t>
-            </a:fld>
-            <a:endParaRPr lang="en-US"/>
-          </a:p>
-        </p:txBody>
-      </p:sp>
-    </p:spTree>
-    <p:extLst>
-      <p:ext uri="{BB962C8B-B14F-4D97-AF65-F5344CB8AC3E}">
-        <p14:creationId xmlns:p14="http://schemas.microsoft.com/office/powerpoint/2010/main" val="1024086991"/>
-      </p:ext>
-    </p:extLst>
-  </p:cSld>
-  <p:clrMapOvr>
-    <a:masterClrMapping/>
-  </p:clrMapOvr>
-</p:notes>
-</file>
-
-<file path=ppt/notesSlides/notesSlide9.xml><?xml version="1.0" encoding="utf-8"?>
-<p:notes xmlns:a="http://schemas.openxmlformats.org/drawingml/2006/main" xmlns:r="http://schemas.openxmlformats.org/officeDocument/2006/relationships" xmlns:p="http://schemas.openxmlformats.org/presentationml/2006/main">
-  <p:cSld>
-    <p:spTree>
-      <p:nvGrpSpPr>
-        <p:cNvPr id="1" name=""/>
-        <p:cNvGrpSpPr/>
-        <p:nvPr/>
-      </p:nvGrpSpPr>
-      <p:grpSpPr>
-        <a:xfrm>
-          <a:off x="0" y="0"/>
-          <a:ext cx="0" cy="0"/>
-          <a:chOff x="0" y="0"/>
-          <a:chExt cx="0" cy="0"/>
-        </a:xfrm>
-      </p:grpSpPr>
-      <p:sp>
-        <p:nvSpPr>
-          <p:cNvPr id="2" name="Slide Image Placeholder 1"/>
-          <p:cNvSpPr>
-            <a:spLocks noGrp="1" noRot="1" noChangeAspect="1"/>
-          </p:cNvSpPr>
-          <p:nvPr>
-            <p:ph type="sldImg"/>
-          </p:nvPr>
-        </p:nvSpPr>
-        <p:spPr/>
-      </p:sp>
-      <p:sp>
-        <p:nvSpPr>
-          <p:cNvPr id="3" name="Notes Placeholder 2"/>
-          <p:cNvSpPr>
-            <a:spLocks noGrp="1"/>
-          </p:cNvSpPr>
-          <p:nvPr>
-            <p:ph type="body" idx="1"/>
-          </p:nvPr>
-        </p:nvSpPr>
-        <p:spPr/>
-        <p:txBody>
-          <a:bodyPr/>
-          <a:lstStyle/>
-          <a:p>
-            <a:r>
-              <a:rPr lang="en-US" dirty="0"/>
-              <a:t>Consigne : discuter des + et des − ; pertinence du modèle par rapport à la réalité.
-Proposition de Claude à partir du code et des mesures : à discuter et à reformuler par Lou et Simon.
-Sorties des parois : mesurées avec mesure_banc.gd (colonne « hors » de soutenance/mesures/resultats.txt), rares, et presque nulles sans fuite.
-Boids : modèle attribué à Craig Reynolds (1987), référence exacte à vérifier avant de la citer.</a:t>
-            </a:r>
-            <a:endParaRPr lang="en-US" dirty="0"/>
-          </a:p>
-        </p:txBody>
-      </p:sp>
-      <p:sp>
-        <p:nvSpPr>
-          <p:cNvPr id="4" name="Slide Number Placeholder 3"/>
-          <p:cNvSpPr>
-            <a:spLocks noGrp="1"/>
-          </p:cNvSpPr>
-          <p:nvPr>
-            <p:ph type="sldNum" sz="quarter" idx="10"/>
-          </p:nvPr>
-        </p:nvSpPr>
-        <p:spPr/>
-        <p:txBody>
-          <a:bodyPr/>
-          <a:lstStyle/>
-          <a:p>
-            <a:fld id="{F7021451-1387-4CA6-816F-3879F97B5CBC}" type="slidenum">
-              <a:rPr lang="en-US"/>
-              <a:t>9</a:t>
             </a:fld>
             <a:endParaRPr lang="en-US"/>
           </a:p>
@@ -2262,543 +1979,6 @@
 </p:sld>
 </file>
 
-<file path=ppt/slides/slide10.xml><?xml version="1.0" encoding="utf-8"?>
-<p:sld xmlns:a="http://schemas.openxmlformats.org/drawingml/2006/main" xmlns:r="http://schemas.openxmlformats.org/officeDocument/2006/relationships" xmlns:p="http://schemas.openxmlformats.org/presentationml/2006/main">
-  <p:cSld name="Slide 10">
-    <p:spTree>
-      <p:nvGrpSpPr>
-        <p:cNvPr id="1" name=""/>
-        <p:cNvGrpSpPr/>
-        <p:nvPr/>
-      </p:nvGrpSpPr>
-      <p:grpSpPr>
-        <a:xfrm>
-          <a:off x="0" y="0"/>
-          <a:ext cx="0" cy="0"/>
-          <a:chOff x="0" y="0"/>
-          <a:chExt cx="0" cy="0"/>
-        </a:xfrm>
-      </p:grpSpPr>
-      <p:sp>
-        <p:nvSpPr>
-          <p:cNvPr id="2" name="Text 2"/>
-          <p:cNvSpPr/>
-          <p:nvPr>
-            <p:ph idx="102" type="title" hasCustomPrompt="1"/>
-          </p:nvPr>
-        </p:nvSpPr>
-        <p:spPr>
-          <a:xfrm>
-            <a:off x="411480" y="548640"/>
-            <a:ext cx="2560320" cy="4114800"/>
-          </a:xfrm>
-          <a:prstGeom prst="rect">
-            <a:avLst/>
-          </a:prstGeom>
-          <a:noFill/>
-          <a:ln/>
-        </p:spPr>
-        <p:txBody>
-          <a:bodyPr wrap="square" lIns="0" tIns="0" rIns="0" bIns="0" rtlCol="0" anchor="t"/>
-          <a:lstStyle/>
-          <a:p>
-            <a:pPr algn="l" indent="0" marL="0">
-              <a:buNone/>
-            </a:pPr>
-            <a:r>
-              <a:rPr lang="en-US" sz="2600" b="1" dirty="0">
-                <a:solidFill>
-                  <a:schemeClr val="bg1"/>
-                </a:solidFill>
-              </a:rPr>
-              <a:t>Perspectives</a:t>
-            </a:r>
-            <a:endParaRPr lang="en-US" sz="2600" dirty="0"/>
-          </a:p>
-        </p:txBody>
-      </p:sp>
-      <p:sp>
-        <p:nvSpPr>
-          <p:cNvPr id="4" name="Carte"/>
-          <p:cNvSpPr/>
-          <p:nvPr/>
-        </p:nvSpPr>
-        <p:spPr>
-          <a:xfrm>
-            <a:off x="3703320" y="1828800"/>
-            <a:ext cx="2587752" cy="3200400"/>
-          </a:xfrm>
-          <a:prstGeom prst="roundRect">
-            <a:avLst>
-              <a:gd name="adj" fmla="val 6360"/>
-            </a:avLst>
-          </a:prstGeom>
-          <a:solidFill>
-            <a:schemeClr val="tx1"/>
-          </a:solidFill>
-          <a:ln w="12700">
-            <a:solidFill>
-              <a:schemeClr val="tx1"/>
-            </a:solidFill>
-            <a:prstDash val="solid"/>
-          </a:ln>
-        </p:spPr>
-      </p:sp>
-      <p:sp>
-        <p:nvSpPr>
-          <p:cNvPr id="5" name="Text 2"/>
-          <p:cNvSpPr txBox="1"/>
-          <p:nvPr/>
-        </p:nvSpPr>
-        <p:spPr>
-          <a:xfrm>
-            <a:off x="3977640" y="2194560"/>
-            <a:ext cx="2103120" cy="822960"/>
-          </a:xfrm>
-          <a:prstGeom prst="rect">
-            <a:avLst/>
-          </a:prstGeom>
-          <a:noFill/>
-          <a:ln/>
-        </p:spPr>
-        <p:txBody>
-          <a:bodyPr wrap="square" lIns="0" tIns="0" rIns="0" bIns="0" rtlCol="0" anchor="t"/>
-          <a:lstStyle/>
-          <a:p>
-            <a:pPr indent="0" marL="0">
-              <a:buNone/>
-            </a:pPr>
-            <a:r>
-              <a:rPr lang="en-US" sz="2400" b="1" dirty="0">
-                <a:solidFill>
-                  <a:schemeClr val="accent2"/>
-                </a:solidFill>
-              </a:rPr>
-              <a:t>Plusieurs rochers</a:t>
-            </a:r>
-            <a:endParaRPr lang="en-US" sz="2400" dirty="0"/>
-          </a:p>
-        </p:txBody>
-      </p:sp>
-      <p:sp>
-        <p:nvSpPr>
-          <p:cNvPr id="6" name="Text 3"/>
-          <p:cNvSpPr txBox="1"/>
-          <p:nvPr/>
-        </p:nvSpPr>
-        <p:spPr>
-          <a:xfrm>
-            <a:off x="3977640" y="3291840"/>
-            <a:ext cx="2103120" cy="1463040"/>
-          </a:xfrm>
-          <a:prstGeom prst="rect">
-            <a:avLst/>
-          </a:prstGeom>
-          <a:noFill/>
-          <a:ln/>
-        </p:spPr>
-        <p:txBody>
-          <a:bodyPr wrap="square" lIns="0" tIns="0" rIns="0" bIns="0" rtlCol="0" anchor="t"/>
-          <a:lstStyle/>
-          <a:p>
-            <a:pPr indent="0" marL="0">
-              <a:buNone/>
-            </a:pPr>
-            <a:r>
-              <a:rPr lang="en-US" sz="1800" dirty="0">
-                <a:solidFill>
-                  <a:schemeClr val="bg1"/>
-                </a:solidFill>
-              </a:rPr>
-              <a:t>dans l'aquarium</a:t>
-            </a:r>
-            <a:endParaRPr lang="en-US" sz="1800" dirty="0"/>
-          </a:p>
-        </p:txBody>
-      </p:sp>
-      <p:sp>
-        <p:nvSpPr>
-          <p:cNvPr id="7" name="Carte"/>
-          <p:cNvSpPr/>
-          <p:nvPr/>
-        </p:nvSpPr>
-        <p:spPr>
-          <a:xfrm>
-            <a:off x="6473952" y="1828800"/>
-            <a:ext cx="2587752" cy="3200400"/>
-          </a:xfrm>
-          <a:prstGeom prst="roundRect">
-            <a:avLst>
-              <a:gd name="adj" fmla="val 6360"/>
-            </a:avLst>
-          </a:prstGeom>
-          <a:solidFill>
-            <a:schemeClr val="tx1"/>
-          </a:solidFill>
-          <a:ln w="12700">
-            <a:solidFill>
-              <a:schemeClr val="tx1"/>
-            </a:solidFill>
-            <a:prstDash val="solid"/>
-          </a:ln>
-        </p:spPr>
-      </p:sp>
-      <p:sp>
-        <p:nvSpPr>
-          <p:cNvPr id="8" name="Text 5"/>
-          <p:cNvSpPr txBox="1"/>
-          <p:nvPr/>
-        </p:nvSpPr>
-        <p:spPr>
-          <a:xfrm>
-            <a:off x="6748272" y="2194560"/>
-            <a:ext cx="2103120" cy="822960"/>
-          </a:xfrm>
-          <a:prstGeom prst="rect">
-            <a:avLst/>
-          </a:prstGeom>
-          <a:noFill/>
-          <a:ln/>
-        </p:spPr>
-        <p:txBody>
-          <a:bodyPr wrap="square" lIns="0" tIns="0" rIns="0" bIns="0" rtlCol="0" anchor="t"/>
-          <a:lstStyle/>
-          <a:p>
-            <a:pPr indent="0" marL="0">
-              <a:buNone/>
-            </a:pPr>
-            <a:r>
-              <a:rPr lang="en-US" sz="2400" b="1" dirty="0">
-                <a:solidFill>
-                  <a:schemeClr val="accent2"/>
-                </a:solidFill>
-              </a:rPr>
-              <a:t>Un courant</a:t>
-            </a:r>
-            <a:endParaRPr lang="en-US" sz="2400" dirty="0"/>
-          </a:p>
-        </p:txBody>
-      </p:sp>
-      <p:sp>
-        <p:nvSpPr>
-          <p:cNvPr id="9" name="Text 6"/>
-          <p:cNvSpPr txBox="1"/>
-          <p:nvPr/>
-        </p:nvSpPr>
-        <p:spPr>
-          <a:xfrm>
-            <a:off x="6748272" y="3291840"/>
-            <a:ext cx="2103120" cy="1463040"/>
-          </a:xfrm>
-          <a:prstGeom prst="rect">
-            <a:avLst/>
-          </a:prstGeom>
-          <a:noFill/>
-          <a:ln/>
-        </p:spPr>
-        <p:txBody>
-          <a:bodyPr wrap="square" lIns="0" tIns="0" rIns="0" bIns="0" rtlCol="0" anchor="t"/>
-          <a:lstStyle/>
-          <a:p>
-            <a:pPr indent="0" marL="0">
-              <a:buNone/>
-            </a:pPr>
-            <a:r>
-              <a:rPr lang="en-US" sz="1800" dirty="0">
-                <a:solidFill>
-                  <a:schemeClr val="bg1"/>
-                </a:solidFill>
-              </a:rPr>
-              <a:t>qui pousse les thons dans une direction</a:t>
-            </a:r>
-            <a:endParaRPr lang="en-US" sz="1800" dirty="0"/>
-          </a:p>
-        </p:txBody>
-      </p:sp>
-      <p:sp>
-        <p:nvSpPr>
-          <p:cNvPr id="10" name="Carte"/>
-          <p:cNvSpPr/>
-          <p:nvPr/>
-        </p:nvSpPr>
-        <p:spPr>
-          <a:xfrm>
-            <a:off x="9244584" y="1828800"/>
-            <a:ext cx="2587752" cy="3200400"/>
-          </a:xfrm>
-          <a:prstGeom prst="roundRect">
-            <a:avLst>
-              <a:gd name="adj" fmla="val 6360"/>
-            </a:avLst>
-          </a:prstGeom>
-          <a:solidFill>
-            <a:schemeClr val="tx1"/>
-          </a:solidFill>
-          <a:ln w="12700">
-            <a:solidFill>
-              <a:schemeClr val="tx1"/>
-            </a:solidFill>
-            <a:prstDash val="solid"/>
-          </a:ln>
-        </p:spPr>
-      </p:sp>
-      <p:sp>
-        <p:nvSpPr>
-          <p:cNvPr id="11" name="Text 8"/>
-          <p:cNvSpPr txBox="1"/>
-          <p:nvPr/>
-        </p:nvSpPr>
-        <p:spPr>
-          <a:xfrm>
-            <a:off x="9518904" y="2194560"/>
-            <a:ext cx="2103120" cy="822960"/>
-          </a:xfrm>
-          <a:prstGeom prst="rect">
-            <a:avLst/>
-          </a:prstGeom>
-          <a:noFill/>
-          <a:ln/>
-        </p:spPr>
-        <p:txBody>
-          <a:bodyPr wrap="square" lIns="0" tIns="0" rIns="0" bIns="0" rtlCol="0" anchor="t"/>
-          <a:lstStyle/>
-          <a:p>
-            <a:pPr indent="0" marL="0">
-              <a:buNone/>
-            </a:pPr>
-            <a:r>
-              <a:rPr lang="en-US" sz="2400" b="1" dirty="0">
-                <a:solidFill>
-                  <a:schemeClr val="accent2"/>
-                </a:solidFill>
-              </a:rPr>
-              <a:t>Une grille spatiale</a:t>
-            </a:r>
-            <a:endParaRPr lang="en-US" sz="2400" dirty="0"/>
-          </a:p>
-        </p:txBody>
-      </p:sp>
-      <p:sp>
-        <p:nvSpPr>
-          <p:cNvPr id="12" name="Text 9"/>
-          <p:cNvSpPr txBox="1"/>
-          <p:nvPr/>
-        </p:nvSpPr>
-        <p:spPr>
-          <a:xfrm>
-            <a:off x="9518904" y="3291840"/>
-            <a:ext cx="2103120" cy="1463040"/>
-          </a:xfrm>
-          <a:prstGeom prst="rect">
-            <a:avLst/>
-          </a:prstGeom>
-          <a:noFill/>
-          <a:ln/>
-        </p:spPr>
-        <p:txBody>
-          <a:bodyPr wrap="square" lIns="0" tIns="0" rIns="0" bIns="0" rtlCol="0" anchor="t"/>
-          <a:lstStyle/>
-          <a:p>
-            <a:pPr indent="0" marL="0">
-              <a:buNone/>
-            </a:pPr>
-            <a:r>
-              <a:rPr lang="en-US" sz="1800" dirty="0">
-                <a:solidFill>
-                  <a:schemeClr val="bg1"/>
-                </a:solidFill>
-              </a:rPr>
-              <a:t>pour chercher les voisins plus vite, avec beaucoup de thons</a:t>
-            </a:r>
-            <a:endParaRPr lang="en-US" sz="1800" dirty="0"/>
-          </a:p>
-        </p:txBody>
-      </p:sp>
-      <p:sp>
-        <p:nvSpPr>
-          <p:cNvPr id="25" name="Slide Number Placeholder 0"/>
-          <p:cNvSpPr>
-            <a:spLocks noGrp="1"/>
-          </p:cNvSpPr>
-          <p:nvPr>
-            <p:ph type="sldNum" sz="quarter" idx="4294967295"/>
-          </p:nvPr>
-        </p:nvSpPr>
-        <p:spPr>
-          <a:xfrm>
-            <a:off x="411480" y="5760720"/>
-            <a:ext cx="1371600" cy="548640"/>
-          </a:xfrm>
-          <a:prstGeom prst="rect">
-            <a:avLst/>
-          </a:prstGeom>
-          <a:extLst>
-            <a:ext uri="{C572A759-6A51-4108-AA02-DFA0A04FC94B}">
-              <ma14:wrappingTextBoxFlag xmlns:ma14="http://schemas.microsoft.com/office/mac/drawingml/2011/main" val="0"/>
-            </a:ext>
-          </a:extLst>
-        </p:spPr>
-        <p:txBody>
-          <a:bodyPr/>
-          <a:lstStyle>
-            <a:lvl1pPr>
-              <a:defRPr sz="3200">
-                <a:solidFill>
-                  <a:schemeClr val="accent2"/>
-                </a:solidFill>
-              </a:defRPr>
-            </a:lvl1pPr>
-          </a:lstStyle>
-          <a:p>
-            <a:pPr algn="l"/>
-            <a:fld id="{F7021451-1387-4CA6-816F-3879F97B5CBC}" type="slidenum">
-              <a:rPr b="1" lang="en-US"/>
-              <a:t>10</a:t>
-            </a:fld>
-            <a:endParaRPr lang="en-US"/>
-          </a:p>
-        </p:txBody>
-      </p:sp>
-    </p:spTree>
-  </p:cSld>
-  <p:clrMapOvr>
-    <a:masterClrMapping/>
-  </p:clrMapOvr>
-</p:sld>
-</file>
-
-<file path=ppt/slides/slide11.xml><?xml version="1.0" encoding="utf-8"?>
-<p:sld xmlns:a="http://schemas.openxmlformats.org/drawingml/2006/main" xmlns:r="http://schemas.openxmlformats.org/officeDocument/2006/relationships" xmlns:p="http://schemas.openxmlformats.org/presentationml/2006/main">
-  <p:cSld name="Slide 11">
-    <p:spTree>
-      <p:nvGrpSpPr>
-        <p:cNvPr id="1" name=""/>
-        <p:cNvGrpSpPr/>
-        <p:nvPr/>
-      </p:nvGrpSpPr>
-      <p:grpSpPr>
-        <a:xfrm>
-          <a:off x="0" y="0"/>
-          <a:ext cx="0" cy="0"/>
-          <a:chOff x="0" y="0"/>
-          <a:chExt cx="0" cy="0"/>
-        </a:xfrm>
-      </p:grpSpPr>
-      <p:sp>
-        <p:nvSpPr>
-          <p:cNvPr id="2" name="Text 2"/>
-          <p:cNvSpPr/>
-          <p:nvPr>
-            <p:ph idx="102" type="title" hasCustomPrompt="1"/>
-          </p:nvPr>
-        </p:nvSpPr>
-        <p:spPr>
-          <a:xfrm>
-            <a:off x="411480" y="548640"/>
-            <a:ext cx="2560320" cy="4114800"/>
-          </a:xfrm>
-          <a:prstGeom prst="rect">
-            <a:avLst/>
-          </a:prstGeom>
-          <a:noFill/>
-          <a:ln/>
-        </p:spPr>
-        <p:txBody>
-          <a:bodyPr wrap="square" lIns="0" tIns="0" rIns="0" bIns="0" rtlCol="0" anchor="t"/>
-          <a:lstStyle/>
-          <a:p>
-            <a:pPr algn="l" indent="0" marL="0">
-              <a:buNone/>
-            </a:pPr>
-            <a:r>
-              <a:rPr lang="en-US" sz="2600" b="1" dirty="0">
-                <a:solidFill>
-                  <a:schemeClr val="bg1"/>
-                </a:solidFill>
-              </a:rPr>
-              <a:t>Annexe : un pas de simulation</a:t>
-            </a:r>
-            <a:endParaRPr lang="en-US" sz="2600" dirty="0"/>
-          </a:p>
-        </p:txBody>
-      </p:sp>
-      <p:pic>
-        <p:nvPicPr>
-          <p:cNvPr id="4" name="Image 0" descr="Annexe : un pas de simulation">    </p:cNvPr>
-          <p:cNvPicPr>
-            <a:picLocks noChangeAspect="1"/>
-          </p:cNvPicPr>
-          <p:nvPr/>
-        </p:nvPicPr>
-        <p:blipFill>
-          <a:blip r:embed="rId1"/>
-          <a:stretch>
-            <a:fillRect/>
-          </a:stretch>
-        </p:blipFill>
-        <p:spPr>
-          <a:xfrm>
-            <a:off x="3383280" y="1005840"/>
-            <a:ext cx="8595360" cy="4834890"/>
-          </a:xfrm>
-          <a:prstGeom prst="rect">
-            <a:avLst/>
-          </a:prstGeom>
-        </p:spPr>
-      </p:pic>
-      <p:sp>
-        <p:nvSpPr>
-          <p:cNvPr id="25" name="Slide Number Placeholder 0"/>
-          <p:cNvSpPr>
-            <a:spLocks noGrp="1"/>
-          </p:cNvSpPr>
-          <p:nvPr>
-            <p:ph type="sldNum" sz="quarter" idx="4294967295"/>
-          </p:nvPr>
-        </p:nvSpPr>
-        <p:spPr>
-          <a:xfrm>
-            <a:off x="411480" y="5760720"/>
-            <a:ext cx="1371600" cy="548640"/>
-          </a:xfrm>
-          <a:prstGeom prst="rect">
-            <a:avLst/>
-          </a:prstGeom>
-          <a:extLst>
-            <a:ext uri="{C572A759-6A51-4108-AA02-DFA0A04FC94B}">
-              <ma14:wrappingTextBoxFlag xmlns:ma14="http://schemas.microsoft.com/office/mac/drawingml/2011/main" val="0"/>
-            </a:ext>
-          </a:extLst>
-        </p:spPr>
-        <p:txBody>
-          <a:bodyPr/>
-          <a:lstStyle>
-            <a:lvl1pPr>
-              <a:defRPr sz="3200">
-                <a:solidFill>
-                  <a:schemeClr val="accent2"/>
-                </a:solidFill>
-              </a:defRPr>
-            </a:lvl1pPr>
-          </a:lstStyle>
-          <a:p>
-            <a:pPr algn="l"/>
-            <a:fld id="{F7021451-1387-4CA6-816F-3879F97B5CBC}" type="slidenum">
-              <a:rPr b="1" lang="en-US"/>
-              <a:t>11</a:t>
-            </a:fld>
-            <a:endParaRPr lang="en-US"/>
-          </a:p>
-        </p:txBody>
-      </p:sp>
-    </p:spTree>
-  </p:cSld>
-  <p:clrMapOvr>
-    <a:masterClrMapping/>
-  </p:clrMapOvr>
-</p:sld>
-</file>
-
 <file path=ppt/slides/slide2.xml><?xml version="1.0" encoding="utf-8"?>
 <p:sld xmlns:a="http://schemas.openxmlformats.org/drawingml/2006/main" xmlns:r="http://schemas.openxmlformats.org/officeDocument/2006/relationships" xmlns:p="http://schemas.openxmlformats.org/presentationml/2006/main">
   <p:cSld name="Slide 2">
@@ -3508,36 +2688,123 @@
                   <a:schemeClr val="bg1"/>
                 </a:solidFill>
               </a:rPr>
-              <a:t>Un départ au hasard</a:t>
+              <a:t>Démonstration</a:t>
             </a:r>
             <a:endParaRPr lang="en-US" sz="2600" dirty="0"/>
           </a:p>
         </p:txBody>
       </p:sp>
-      <p:pic>
-        <p:nvPicPr>
-          <p:cNvPr id="4" name="Image 0" descr="Un départ au hasard">    </p:cNvPr>
-          <p:cNvPicPr>
-            <a:picLocks noChangeAspect="1"/>
-          </p:cNvPicPr>
+      <p:sp>
+        <p:nvSpPr>
+          <p:cNvPr id="4" name="Disque"/>
+          <p:cNvSpPr/>
           <p:nvPr/>
-        </p:nvPicPr>
-        <p:blipFill>
-          <a:blip r:embed="rId1"/>
-          <a:stretch>
-            <a:fillRect/>
-          </a:stretch>
-        </p:blipFill>
-        <p:spPr>
-          <a:xfrm>
-            <a:off x="3383280" y="1005840"/>
-            <a:ext cx="8595360" cy="4834890"/>
-          </a:xfrm>
-          <a:prstGeom prst="rect">
-            <a:avLst/>
-          </a:prstGeom>
-        </p:spPr>
-      </p:pic>
+        </p:nvSpPr>
+        <p:spPr>
+          <a:xfrm>
+            <a:off x="7909560" y="1463040"/>
+            <a:ext cx="3840480" cy="3840480"/>
+          </a:xfrm>
+          <a:prstGeom prst="ellipse">
+            <a:avLst/>
+          </a:prstGeom>
+          <a:solidFill>
+            <a:schemeClr val="accent2"/>
+          </a:solidFill>
+          <a:ln w="12700">
+            <a:solidFill>
+              <a:schemeClr val="accent2"/>
+            </a:solidFill>
+            <a:prstDash val="solid"/>
+          </a:ln>
+        </p:spPr>
+      </p:sp>
+      <p:sp>
+        <p:nvSpPr>
+          <p:cNvPr id="5" name="Text 2"/>
+          <p:cNvSpPr txBox="1"/>
+          <p:nvPr/>
+        </p:nvSpPr>
+        <p:spPr>
+          <a:xfrm>
+            <a:off x="3703320" y="1737360"/>
+            <a:ext cx="6858000" cy="2560320"/>
+          </a:xfrm>
+          <a:prstGeom prst="rect">
+            <a:avLst/>
+          </a:prstGeom>
+          <a:noFill/>
+          <a:ln/>
+        </p:spPr>
+        <p:txBody>
+          <a:bodyPr wrap="square" lIns="0" tIns="0" rIns="0" bIns="0" rtlCol="0" anchor="t"/>
+          <a:lstStyle/>
+          <a:p>
+            <a:pPr indent="0" marL="0">
+              <a:buNone/>
+            </a:pPr>
+            <a:r>
+              <a:rPr lang="en-US" sz="8000" b="1" dirty="0">
+                <a:solidFill>
+                  <a:schemeClr val="tx1"/>
+                </a:solidFill>
+              </a:rPr>
+              <a:t>Place</a:t>
+            </a:r>
+            <a:endParaRPr lang="en-US" sz="8000" dirty="0"/>
+          </a:p>
+          <a:p>
+            <a:pPr indent="0" marL="0">
+              <a:buNone/>
+            </a:pPr>
+            <a:r>
+              <a:rPr lang="en-US" sz="8000" b="1" dirty="0">
+                <a:solidFill>
+                  <a:schemeClr val="tx1"/>
+                </a:solidFill>
+              </a:rPr>
+              <a:t>à la démo</a:t>
+            </a:r>
+            <a:endParaRPr lang="en-US" sz="8000" dirty="0"/>
+          </a:p>
+        </p:txBody>
+      </p:sp>
+      <p:sp>
+        <p:nvSpPr>
+          <p:cNvPr id="6" name="Text 3"/>
+          <p:cNvSpPr txBox="1"/>
+          <p:nvPr/>
+        </p:nvSpPr>
+        <p:spPr>
+          <a:xfrm>
+            <a:off x="3703320" y="4572000"/>
+            <a:ext cx="6858000" cy="548640"/>
+          </a:xfrm>
+          <a:prstGeom prst="rect">
+            <a:avLst/>
+          </a:prstGeom>
+          <a:noFill/>
+          <a:ln/>
+        </p:spPr>
+        <p:txBody>
+          <a:bodyPr wrap="square" lIns="0" tIns="0" rIns="0" bIns="0" rtlCol="0" anchor="ctr"/>
+          <a:lstStyle/>
+          <a:p>
+            <a:pPr indent="0" marL="0">
+              <a:buNone/>
+            </a:pPr>
+            <a:r>
+              <a:rPr lang="en-US" sz="2400" dirty="0">
+                <a:solidFill>
+                  <a:schemeClr val="accent1"/>
+                </a:solidFill>
+              </a:rPr>
+              <a:t>On plonge dans l'aquarium.</a:t>
+            </a:r>
+            <a:endParaRPr lang="en-US" sz="2400" dirty="0"/>
+          </a:p>
+        </p:txBody>
+      </p:sp>
       <p:sp>
         <p:nvSpPr>
           <p:cNvPr id="25" name="Slide Number Placeholder 0"/>
@@ -3640,7 +2907,7 @@
                   <a:schemeClr val="bg1"/>
                 </a:solidFill>
               </a:rPr>
-              <a:t>Démonstration</a:t>
+              <a:t>Perspectives</a:t>
             </a:r>
             <a:endParaRPr lang="en-US" sz="2600" dirty="0"/>
           </a:p>
@@ -3648,7 +2915,7 @@
       </p:sp>
       <p:sp>
         <p:nvSpPr>
-          <p:cNvPr id="4" name="Étape 1"/>
+          <p:cNvPr id="4" name="Carte"/>
           <p:cNvSpPr/>
           <p:nvPr/>
         </p:nvSpPr>
@@ -3675,75 +2942,14 @@
       </p:sp>
       <p:sp>
         <p:nvSpPr>
-          <p:cNvPr id="5" name="Pastille 1"/>
-          <p:cNvSpPr/>
-          <p:nvPr/>
-        </p:nvSpPr>
-        <p:spPr>
-          <a:xfrm>
-            <a:off x="3931920" y="1645920"/>
-            <a:ext cx="640080" cy="640080"/>
-          </a:xfrm>
-          <a:prstGeom prst="ellipse">
-            <a:avLst/>
-          </a:prstGeom>
-          <a:solidFill>
-            <a:schemeClr val="accent2"/>
-          </a:solidFill>
-          <a:ln w="12700">
-            <a:solidFill>
-              <a:schemeClr val="accent2"/>
-            </a:solidFill>
-            <a:prstDash val="solid"/>
-          </a:ln>
-        </p:spPr>
-      </p:sp>
-      <p:sp>
-        <p:nvSpPr>
-          <p:cNvPr id="6" name="Text 3"/>
+          <p:cNvPr id="5" name="Text 2"/>
           <p:cNvSpPr txBox="1"/>
           <p:nvPr/>
         </p:nvSpPr>
         <p:spPr>
           <a:xfrm>
-            <a:off x="3931920" y="1645920"/>
-            <a:ext cx="640080" cy="640080"/>
-          </a:xfrm>
-          <a:prstGeom prst="rect">
-            <a:avLst/>
-          </a:prstGeom>
-          <a:noFill/>
-          <a:ln/>
-        </p:spPr>
-        <p:txBody>
-          <a:bodyPr wrap="square" lIns="0" tIns="0" rIns="0" bIns="0" rtlCol="0" anchor="ctr"/>
-          <a:lstStyle/>
-          <a:p>
-            <a:pPr algn="ctr" indent="0" marL="0">
-              <a:buNone/>
-            </a:pPr>
-            <a:r>
-              <a:rPr lang="en-US" sz="2400" b="1" dirty="0">
-                <a:solidFill>
-                  <a:schemeClr val="tx1"/>
-                </a:solidFill>
-              </a:rPr>
-              <a:t>1</a:t>
-            </a:r>
-            <a:endParaRPr lang="en-US" sz="2400" dirty="0"/>
-          </a:p>
-        </p:txBody>
-      </p:sp>
-      <p:sp>
-        <p:nvSpPr>
-          <p:cNvPr id="7" name="Text 4"/>
-          <p:cNvSpPr txBox="1"/>
-          <p:nvPr/>
-        </p:nvSpPr>
-        <p:spPr>
-          <a:xfrm>
-            <a:off x="3931920" y="2560320"/>
-            <a:ext cx="1508760" cy="1371600"/>
+            <a:off x="3931920" y="1737360"/>
+            <a:ext cx="1463040" cy="1371600"/>
           </a:xfrm>
           <a:prstGeom prst="rect">
             <a:avLst/>
@@ -3759,27 +2965,27 @@
               <a:buNone/>
             </a:pPr>
             <a:r>
-              <a:rPr lang="en-US" sz="2000" b="1" dirty="0">
+              <a:rPr lang="en-US" sz="2200" b="1" dirty="0">
                 <a:solidFill>
-                  <a:schemeClr val="bg1"/>
+                  <a:schemeClr val="accent2"/>
                 </a:solidFill>
               </a:rPr>
-              <a:t>Plonger</a:t>
+              <a:t>Un bateau de pêche</a:t>
             </a:r>
-            <a:endParaRPr lang="en-US" sz="2000" dirty="0"/>
-          </a:p>
-        </p:txBody>
-      </p:sp>
-      <p:sp>
-        <p:nvSpPr>
-          <p:cNvPr id="8" name="Text 5"/>
+            <a:endParaRPr lang="en-US" sz="2200" dirty="0"/>
+          </a:p>
+        </p:txBody>
+      </p:sp>
+      <p:sp>
+        <p:nvSpPr>
+          <p:cNvPr id="6" name="Text 3"/>
           <p:cNvSpPr txBox="1"/>
           <p:nvPr/>
         </p:nvSpPr>
         <p:spPr>
           <a:xfrm>
-            <a:off x="3931920" y="4023360"/>
-            <a:ext cx="1508760" cy="1280160"/>
+            <a:off x="3931920" y="3291840"/>
+            <a:ext cx="1463040" cy="2011680"/>
           </a:xfrm>
           <a:prstGeom prst="rect">
             <a:avLst/>
@@ -3797,10 +3003,10 @@
             <a:r>
               <a:rPr lang="en-US" sz="1600" dirty="0">
                 <a:solidFill>
-                  <a:schemeClr val="bg2"/>
+                  <a:schemeClr val="bg1"/>
                 </a:solidFill>
               </a:rPr>
-              <a:t>Le banc se forme, le requin le suit et le coupe</a:t>
+              <a:t>qui traîne un filet : il attrape les thons, qui le fuient</a:t>
             </a:r>
             <a:endParaRPr lang="en-US" sz="1600" dirty="0"/>
           </a:p>
@@ -3808,7 +3014,7 @@
       </p:sp>
       <p:sp>
         <p:nvSpPr>
-          <p:cNvPr id="9" name="Étape 2"/>
+          <p:cNvPr id="7" name="Carte"/>
           <p:cNvSpPr/>
           <p:nvPr/>
         </p:nvSpPr>
@@ -3835,75 +3041,14 @@
       </p:sp>
       <p:sp>
         <p:nvSpPr>
-          <p:cNvPr id="10" name="Pastille 2"/>
-          <p:cNvSpPr/>
-          <p:nvPr/>
-        </p:nvSpPr>
-        <p:spPr>
-          <a:xfrm>
-            <a:off x="6007608" y="1645920"/>
-            <a:ext cx="640080" cy="640080"/>
-          </a:xfrm>
-          <a:prstGeom prst="ellipse">
-            <a:avLst/>
-          </a:prstGeom>
-          <a:solidFill>
-            <a:schemeClr val="accent2"/>
-          </a:solidFill>
-          <a:ln w="12700">
-            <a:solidFill>
-              <a:schemeClr val="accent2"/>
-            </a:solidFill>
-            <a:prstDash val="solid"/>
-          </a:ln>
-        </p:spPr>
-      </p:sp>
-      <p:sp>
-        <p:nvSpPr>
-          <p:cNvPr id="11" name="Text 8"/>
+          <p:cNvPr id="8" name="Text 5"/>
           <p:cNvSpPr txBox="1"/>
           <p:nvPr/>
         </p:nvSpPr>
         <p:spPr>
           <a:xfrm>
-            <a:off x="6007608" y="1645920"/>
-            <a:ext cx="640080" cy="640080"/>
-          </a:xfrm>
-          <a:prstGeom prst="rect">
-            <a:avLst/>
-          </a:prstGeom>
-          <a:noFill/>
-          <a:ln/>
-        </p:spPr>
-        <p:txBody>
-          <a:bodyPr wrap="square" lIns="0" tIns="0" rIns="0" bIns="0" rtlCol="0" anchor="ctr"/>
-          <a:lstStyle/>
-          <a:p>
-            <a:pPr algn="ctr" indent="0" marL="0">
-              <a:buNone/>
-            </a:pPr>
-            <a:r>
-              <a:rPr lang="en-US" sz="2400" b="1" dirty="0">
-                <a:solidFill>
-                  <a:schemeClr val="tx1"/>
-                </a:solidFill>
-              </a:rPr>
-              <a:t>2</a:t>
-            </a:r>
-            <a:endParaRPr lang="en-US" sz="2400" dirty="0"/>
-          </a:p>
-        </p:txBody>
-      </p:sp>
-      <p:sp>
-        <p:nvSpPr>
-          <p:cNvPr id="12" name="Text 9"/>
-          <p:cNvSpPr txBox="1"/>
-          <p:nvPr/>
-        </p:nvSpPr>
-        <p:spPr>
-          <a:xfrm>
-            <a:off x="6007608" y="2560320"/>
-            <a:ext cx="1508760" cy="1371600"/>
+            <a:off x="6007608" y="1737360"/>
+            <a:ext cx="1463040" cy="1371600"/>
           </a:xfrm>
           <a:prstGeom prst="rect">
             <a:avLst/>
@@ -3919,27 +3064,27 @@
               <a:buNone/>
             </a:pPr>
             <a:r>
-              <a:rPr lang="en-US" sz="2000" b="1" dirty="0">
+              <a:rPr lang="en-US" sz="2200" b="1" dirty="0">
                 <a:solidFill>
-                  <a:schemeClr val="bg1"/>
+                  <a:schemeClr val="accent2"/>
                 </a:solidFill>
               </a:rPr>
-              <a:t>Vision à 4</a:t>
+              <a:t>Plusieurs rochers</a:t>
             </a:r>
-            <a:endParaRPr lang="en-US" sz="2000" dirty="0"/>
-          </a:p>
-        </p:txBody>
-      </p:sp>
-      <p:sp>
-        <p:nvSpPr>
-          <p:cNvPr id="13" name="Text 10"/>
+            <a:endParaRPr lang="en-US" sz="2200" dirty="0"/>
+          </a:p>
+        </p:txBody>
+      </p:sp>
+      <p:sp>
+        <p:nvSpPr>
+          <p:cNvPr id="9" name="Text 6"/>
           <p:cNvSpPr txBox="1"/>
           <p:nvPr/>
         </p:nvSpPr>
         <p:spPr>
           <a:xfrm>
-            <a:off x="6007608" y="4023360"/>
-            <a:ext cx="1508760" cy="1280160"/>
+            <a:off x="6007608" y="3291840"/>
+            <a:ext cx="1463040" cy="2011680"/>
           </a:xfrm>
           <a:prstGeom prst="rect">
             <a:avLst/>
@@ -3957,10 +3102,10 @@
             <a:r>
               <a:rPr lang="en-US" sz="1600" dirty="0">
                 <a:solidFill>
-                  <a:schemeClr val="bg2"/>
+                  <a:schemeClr val="bg1"/>
                 </a:solidFill>
               </a:rPr>
-              <a:t>Le banc se disperse en petits groupes</a:t>
+              <a:t>dans l'aquarium</a:t>
             </a:r>
             <a:endParaRPr lang="en-US" sz="1600" dirty="0"/>
           </a:p>
@@ -3968,7 +3113,7 @@
       </p:sp>
       <p:sp>
         <p:nvSpPr>
-          <p:cNvPr id="14" name="Étape 3"/>
+          <p:cNvPr id="10" name="Carte"/>
           <p:cNvSpPr/>
           <p:nvPr/>
         </p:nvSpPr>
@@ -3995,75 +3140,14 @@
       </p:sp>
       <p:sp>
         <p:nvSpPr>
-          <p:cNvPr id="15" name="Pastille 3"/>
-          <p:cNvSpPr/>
-          <p:nvPr/>
-        </p:nvSpPr>
-        <p:spPr>
-          <a:xfrm>
-            <a:off x="8083296" y="1645920"/>
-            <a:ext cx="640080" cy="640080"/>
-          </a:xfrm>
-          <a:prstGeom prst="ellipse">
-            <a:avLst/>
-          </a:prstGeom>
-          <a:solidFill>
-            <a:schemeClr val="accent2"/>
-          </a:solidFill>
-          <a:ln w="12700">
-            <a:solidFill>
-              <a:schemeClr val="accent2"/>
-            </a:solidFill>
-            <a:prstDash val="solid"/>
-          </a:ln>
-        </p:spPr>
-      </p:sp>
-      <p:sp>
-        <p:nvSpPr>
-          <p:cNvPr id="16" name="Text 13"/>
+          <p:cNvPr id="11" name="Text 8"/>
           <p:cNvSpPr txBox="1"/>
           <p:nvPr/>
         </p:nvSpPr>
         <p:spPr>
           <a:xfrm>
-            <a:off x="8083296" y="1645920"/>
-            <a:ext cx="640080" cy="640080"/>
-          </a:xfrm>
-          <a:prstGeom prst="rect">
-            <a:avLst/>
-          </a:prstGeom>
-          <a:noFill/>
-          <a:ln/>
-        </p:spPr>
-        <p:txBody>
-          <a:bodyPr wrap="square" lIns="0" tIns="0" rIns="0" bIns="0" rtlCol="0" anchor="ctr"/>
-          <a:lstStyle/>
-          <a:p>
-            <a:pPr algn="ctr" indent="0" marL="0">
-              <a:buNone/>
-            </a:pPr>
-            <a:r>
-              <a:rPr lang="en-US" sz="2400" b="1" dirty="0">
-                <a:solidFill>
-                  <a:schemeClr val="tx1"/>
-                </a:solidFill>
-              </a:rPr>
-              <a:t>3</a:t>
-            </a:r>
-            <a:endParaRPr lang="en-US" sz="2400" dirty="0"/>
-          </a:p>
-        </p:txBody>
-      </p:sp>
-      <p:sp>
-        <p:nvSpPr>
-          <p:cNvPr id="17" name="Text 14"/>
-          <p:cNvSpPr txBox="1"/>
-          <p:nvPr/>
-        </p:nvSpPr>
-        <p:spPr>
-          <a:xfrm>
-            <a:off x="8083296" y="2560320"/>
-            <a:ext cx="1508760" cy="1371600"/>
+            <a:off x="8083296" y="1737360"/>
+            <a:ext cx="1463040" cy="1371600"/>
           </a:xfrm>
           <a:prstGeom prst="rect">
             <a:avLst/>
@@ -4079,27 +3163,27 @@
               <a:buNone/>
             </a:pPr>
             <a:r>
-              <a:rPr lang="en-US" sz="2000" b="1" dirty="0">
+              <a:rPr lang="en-US" sz="2200" b="1" dirty="0">
                 <a:solidFill>
-                  <a:schemeClr val="bg1"/>
+                  <a:schemeClr val="accent2"/>
                 </a:solidFill>
               </a:rPr>
-              <a:t>Alignement à 0</a:t>
+              <a:t>Un courant</a:t>
             </a:r>
-            <a:endParaRPr lang="en-US" sz="2000" dirty="0"/>
-          </a:p>
-        </p:txBody>
-      </p:sp>
-      <p:sp>
-        <p:nvSpPr>
-          <p:cNvPr id="18" name="Text 15"/>
+            <a:endParaRPr lang="en-US" sz="2200" dirty="0"/>
+          </a:p>
+        </p:txBody>
+      </p:sp>
+      <p:sp>
+        <p:nvSpPr>
+          <p:cNvPr id="12" name="Text 9"/>
           <p:cNvSpPr txBox="1"/>
           <p:nvPr/>
         </p:nvSpPr>
         <p:spPr>
           <a:xfrm>
-            <a:off x="8083296" y="4023360"/>
-            <a:ext cx="1508760" cy="1280160"/>
+            <a:off x="8083296" y="3291840"/>
+            <a:ext cx="1463040" cy="2011680"/>
           </a:xfrm>
           <a:prstGeom prst="rect">
             <a:avLst/>
@@ -4117,10 +3201,10 @@
             <a:r>
               <a:rPr lang="en-US" sz="1600" dirty="0">
                 <a:solidFill>
-                  <a:schemeClr val="bg2"/>
+                  <a:schemeClr val="bg1"/>
                 </a:solidFill>
               </a:rPr>
-              <a:t>Chacun nage dans son sens</a:t>
+              <a:t>qui pousse les thons dans une direction</a:t>
             </a:r>
             <a:endParaRPr lang="en-US" sz="1600" dirty="0"/>
           </a:p>
@@ -4128,7 +3212,7 @@
       </p:sp>
       <p:sp>
         <p:nvSpPr>
-          <p:cNvPr id="19" name="Étape 4"/>
+          <p:cNvPr id="13" name="Carte"/>
           <p:cNvSpPr/>
           <p:nvPr/>
         </p:nvSpPr>
@@ -4155,75 +3239,14 @@
       </p:sp>
       <p:sp>
         <p:nvSpPr>
-          <p:cNvPr id="20" name="Pastille 4"/>
-          <p:cNvSpPr/>
-          <p:nvPr/>
-        </p:nvSpPr>
-        <p:spPr>
-          <a:xfrm>
-            <a:off x="10158984" y="1645920"/>
-            <a:ext cx="640080" cy="640080"/>
-          </a:xfrm>
-          <a:prstGeom prst="ellipse">
-            <a:avLst/>
-          </a:prstGeom>
-          <a:solidFill>
-            <a:schemeClr val="accent2"/>
-          </a:solidFill>
-          <a:ln w="12700">
-            <a:solidFill>
-              <a:schemeClr val="accent2"/>
-            </a:solidFill>
-            <a:prstDash val="solid"/>
-          </a:ln>
-        </p:spPr>
-      </p:sp>
-      <p:sp>
-        <p:nvSpPr>
-          <p:cNvPr id="21" name="Text 18"/>
+          <p:cNvPr id="14" name="Text 11"/>
           <p:cNvSpPr txBox="1"/>
           <p:nvPr/>
         </p:nvSpPr>
         <p:spPr>
           <a:xfrm>
-            <a:off x="10158984" y="1645920"/>
-            <a:ext cx="640080" cy="640080"/>
-          </a:xfrm>
-          <a:prstGeom prst="rect">
-            <a:avLst/>
-          </a:prstGeom>
-          <a:noFill/>
-          <a:ln/>
-        </p:spPr>
-        <p:txBody>
-          <a:bodyPr wrap="square" lIns="0" tIns="0" rIns="0" bIns="0" rtlCol="0" anchor="ctr"/>
-          <a:lstStyle/>
-          <a:p>
-            <a:pPr algn="ctr" indent="0" marL="0">
-              <a:buNone/>
-            </a:pPr>
-            <a:r>
-              <a:rPr lang="en-US" sz="2400" b="1" dirty="0">
-                <a:solidFill>
-                  <a:schemeClr val="tx1"/>
-                </a:solidFill>
-              </a:rPr>
-              <a:t>4</a:t>
-            </a:r>
-            <a:endParaRPr lang="en-US" sz="2400" dirty="0"/>
-          </a:p>
-        </p:txBody>
-      </p:sp>
-      <p:sp>
-        <p:nvSpPr>
-          <p:cNvPr id="22" name="Text 19"/>
-          <p:cNvSpPr txBox="1"/>
-          <p:nvPr/>
-        </p:nvSpPr>
-        <p:spPr>
-          <a:xfrm>
-            <a:off x="10158984" y="2560320"/>
-            <a:ext cx="1508760" cy="1371600"/>
+            <a:off x="10158984" y="1737360"/>
+            <a:ext cx="1463040" cy="1371600"/>
           </a:xfrm>
           <a:prstGeom prst="rect">
             <a:avLst/>
@@ -4239,27 +3262,27 @@
               <a:buNone/>
             </a:pPr>
             <a:r>
-              <a:rPr lang="en-US" sz="2000" b="1" dirty="0">
+              <a:rPr lang="en-US" sz="2200" b="1" dirty="0">
                 <a:solidFill>
-                  <a:schemeClr val="bg1"/>
+                  <a:schemeClr val="accent2"/>
                 </a:solidFill>
               </a:rPr>
-              <a:t>Valeurs par défaut, Relancer</a:t>
+              <a:t>Une grille spatiale</a:t>
             </a:r>
-            <a:endParaRPr lang="en-US" sz="2000" dirty="0"/>
-          </a:p>
-        </p:txBody>
-      </p:sp>
-      <p:sp>
-        <p:nvSpPr>
-          <p:cNvPr id="23" name="Text 20"/>
+            <a:endParaRPr lang="en-US" sz="2200" dirty="0"/>
+          </a:p>
+        </p:txBody>
+      </p:sp>
+      <p:sp>
+        <p:nvSpPr>
+          <p:cNvPr id="15" name="Text 12"/>
           <p:cNvSpPr txBox="1"/>
           <p:nvPr/>
         </p:nvSpPr>
         <p:spPr>
           <a:xfrm>
-            <a:off x="10158984" y="4023360"/>
-            <a:ext cx="1508760" cy="1280160"/>
+            <a:off x="10158984" y="3291840"/>
+            <a:ext cx="1463040" cy="2011680"/>
           </a:xfrm>
           <a:prstGeom prst="rect">
             <a:avLst/>
@@ -4277,10 +3300,10 @@
             <a:r>
               <a:rPr lang="en-US" sz="1600" dirty="0">
                 <a:solidFill>
-                  <a:schemeClr val="bg2"/>
+                  <a:schemeClr val="bg1"/>
                 </a:solidFill>
               </a:rPr>
-              <a:t>Nouveau départ au hasard, le banc revient</a:t>
+              <a:t>pour chercher les voisins plus vite, avec beaucoup de thons</a:t>
             </a:r>
             <a:endParaRPr lang="en-US" sz="1600" dirty="0"/>
           </a:p>
@@ -4326,614 +3349,6 @@
             <a:fld id="{F7021451-1387-4CA6-816F-3879F97B5CBC}" type="slidenum">
               <a:rPr b="1" lang="en-US"/>
               <a:t>8</a:t>
-            </a:fld>
-            <a:endParaRPr lang="en-US"/>
-          </a:p>
-        </p:txBody>
-      </p:sp>
-    </p:spTree>
-  </p:cSld>
-  <p:clrMapOvr>
-    <a:masterClrMapping/>
-  </p:clrMapOvr>
-</p:sld>
-</file>
-
-<file path=ppt/slides/slide9.xml><?xml version="1.0" encoding="utf-8"?>
-<p:sld xmlns:a="http://schemas.openxmlformats.org/drawingml/2006/main" xmlns:r="http://schemas.openxmlformats.org/officeDocument/2006/relationships" xmlns:p="http://schemas.openxmlformats.org/presentationml/2006/main">
-  <p:cSld name="Slide 9">
-    <p:spTree>
-      <p:nvGrpSpPr>
-        <p:cNvPr id="1" name=""/>
-        <p:cNvGrpSpPr/>
-        <p:nvPr/>
-      </p:nvGrpSpPr>
-      <p:grpSpPr>
-        <a:xfrm>
-          <a:off x="0" y="0"/>
-          <a:ext cx="0" cy="0"/>
-          <a:chOff x="0" y="0"/>
-          <a:chExt cx="0" cy="0"/>
-        </a:xfrm>
-      </p:grpSpPr>
-      <p:sp>
-        <p:nvSpPr>
-          <p:cNvPr id="2" name="Text 2"/>
-          <p:cNvSpPr/>
-          <p:nvPr>
-            <p:ph idx="102" type="title" hasCustomPrompt="1"/>
-          </p:nvPr>
-        </p:nvSpPr>
-        <p:spPr>
-          <a:xfrm>
-            <a:off x="411480" y="548640"/>
-            <a:ext cx="2560320" cy="4114800"/>
-          </a:xfrm>
-          <a:prstGeom prst="rect">
-            <a:avLst/>
-          </a:prstGeom>
-          <a:noFill/>
-          <a:ln/>
-        </p:spPr>
-        <p:txBody>
-          <a:bodyPr wrap="square" lIns="0" tIns="0" rIns="0" bIns="0" rtlCol="0" anchor="t"/>
-          <a:lstStyle/>
-          <a:p>
-            <a:pPr algn="l" indent="0" marL="0">
-              <a:buNone/>
-            </a:pPr>
-            <a:r>
-              <a:rPr lang="en-US" sz="2600" b="1" dirty="0">
-                <a:solidFill>
-                  <a:schemeClr val="bg1"/>
-                </a:solidFill>
-              </a:rPr>
-              <a:t>Les + et les −</a:t>
-            </a:r>
-            <a:endParaRPr lang="en-US" sz="2600" dirty="0"/>
-          </a:p>
-        </p:txBody>
-      </p:sp>
-      <p:sp>
-        <p:nvSpPr>
-          <p:cNvPr id="4" name="Pastille +"/>
-          <p:cNvSpPr/>
-          <p:nvPr/>
-        </p:nvSpPr>
-        <p:spPr>
-          <a:xfrm>
-            <a:off x="3703320" y="1005840"/>
-            <a:ext cx="640080" cy="640080"/>
-          </a:xfrm>
-          <a:prstGeom prst="ellipse">
-            <a:avLst/>
-          </a:prstGeom>
-          <a:solidFill>
-            <a:schemeClr val="accent5"/>
-          </a:solidFill>
-          <a:ln w="12700">
-            <a:solidFill>
-              <a:schemeClr val="accent5"/>
-            </a:solidFill>
-            <a:prstDash val="solid"/>
-          </a:ln>
-        </p:spPr>
-      </p:sp>
-      <p:sp>
-        <p:nvSpPr>
-          <p:cNvPr id="5" name="Text 2"/>
-          <p:cNvSpPr txBox="1"/>
-          <p:nvPr/>
-        </p:nvSpPr>
-        <p:spPr>
-          <a:xfrm>
-            <a:off x="3703320" y="1005840"/>
-            <a:ext cx="640080" cy="640080"/>
-          </a:xfrm>
-          <a:prstGeom prst="rect">
-            <a:avLst/>
-          </a:prstGeom>
-          <a:noFill/>
-          <a:ln/>
-        </p:spPr>
-        <p:txBody>
-          <a:bodyPr wrap="square" lIns="0" tIns="0" rIns="0" bIns="0" rtlCol="0" anchor="ctr"/>
-          <a:lstStyle/>
-          <a:p>
-            <a:pPr algn="ctr" indent="0" marL="0">
-              <a:buNone/>
-            </a:pPr>
-            <a:r>
-              <a:rPr lang="en-US" sz="2400" b="1" dirty="0">
-                <a:solidFill>
-                  <a:schemeClr val="bg1"/>
-                </a:solidFill>
-              </a:rPr>
-              <a:t>+</a:t>
-            </a:r>
-            <a:endParaRPr lang="en-US" sz="2400" dirty="0"/>
-          </a:p>
-        </p:txBody>
-      </p:sp>
-      <p:sp>
-        <p:nvSpPr>
-          <p:cNvPr id="6" name="Carte"/>
-          <p:cNvSpPr/>
-          <p:nvPr/>
-        </p:nvSpPr>
-        <p:spPr>
-          <a:xfrm>
-            <a:off x="3703320" y="1920240"/>
-            <a:ext cx="3977640" cy="1188720"/>
-          </a:xfrm>
-          <a:prstGeom prst="roundRect">
-            <a:avLst>
-              <a:gd name="adj" fmla="val 13846"/>
-            </a:avLst>
-          </a:prstGeom>
-          <a:solidFill>
-            <a:schemeClr val="bg2"/>
-          </a:solidFill>
-          <a:ln w="12700">
-            <a:solidFill>
-              <a:schemeClr val="bg2"/>
-            </a:solidFill>
-            <a:prstDash val="solid"/>
-          </a:ln>
-        </p:spPr>
-      </p:sp>
-      <p:sp>
-        <p:nvSpPr>
-          <p:cNvPr id="7" name="Text 4"/>
-          <p:cNvSpPr txBox="1"/>
-          <p:nvPr/>
-        </p:nvSpPr>
-        <p:spPr>
-          <a:xfrm>
-            <a:off x="3931920" y="1920240"/>
-            <a:ext cx="3520440" cy="1188720"/>
-          </a:xfrm>
-          <a:prstGeom prst="rect">
-            <a:avLst/>
-          </a:prstGeom>
-          <a:noFill/>
-          <a:ln/>
-        </p:spPr>
-        <p:txBody>
-          <a:bodyPr wrap="square" lIns="0" tIns="0" rIns="0" bIns="0" rtlCol="0" anchor="ctr"/>
-          <a:lstStyle/>
-          <a:p>
-            <a:pPr indent="0" marL="0">
-              <a:buNone/>
-            </a:pPr>
-            <a:r>
-              <a:rPr lang="en-US" sz="1600" dirty="0">
-                <a:solidFill>
-                  <a:schemeClr val="tx1"/>
-                </a:solidFill>
-              </a:rPr>
-              <a:t>Un banc sans chef : chaque thon ne regarde que ses voisins</a:t>
-            </a:r>
-            <a:endParaRPr lang="en-US" sz="1600" dirty="0"/>
-          </a:p>
-        </p:txBody>
-      </p:sp>
-      <p:sp>
-        <p:nvSpPr>
-          <p:cNvPr id="8" name="Carte"/>
-          <p:cNvSpPr/>
-          <p:nvPr/>
-        </p:nvSpPr>
-        <p:spPr>
-          <a:xfrm>
-            <a:off x="3703320" y="3291840"/>
-            <a:ext cx="3977640" cy="1188720"/>
-          </a:xfrm>
-          <a:prstGeom prst="roundRect">
-            <a:avLst>
-              <a:gd name="adj" fmla="val 13846"/>
-            </a:avLst>
-          </a:prstGeom>
-          <a:solidFill>
-            <a:schemeClr val="bg2"/>
-          </a:solidFill>
-          <a:ln w="12700">
-            <a:solidFill>
-              <a:schemeClr val="bg2"/>
-            </a:solidFill>
-            <a:prstDash val="solid"/>
-          </a:ln>
-        </p:spPr>
-      </p:sp>
-      <p:sp>
-        <p:nvSpPr>
-          <p:cNvPr id="9" name="Text 6"/>
-          <p:cNvSpPr txBox="1"/>
-          <p:nvPr/>
-        </p:nvSpPr>
-        <p:spPr>
-          <a:xfrm>
-            <a:off x="3931920" y="3291840"/>
-            <a:ext cx="3520440" cy="1188720"/>
-          </a:xfrm>
-          <a:prstGeom prst="rect">
-            <a:avLst/>
-          </a:prstGeom>
-          <a:noFill/>
-          <a:ln/>
-        </p:spPr>
-        <p:txBody>
-          <a:bodyPr wrap="square" lIns="0" tIns="0" rIns="0" bIns="0" rtlCol="0" anchor="ctr"/>
-          <a:lstStyle/>
-          <a:p>
-            <a:pPr indent="0" marL="0">
-              <a:buNone/>
-            </a:pPr>
-            <a:r>
-              <a:rPr lang="en-US" sz="1600" dirty="0">
-                <a:solidFill>
-                  <a:schemeClr val="tx1"/>
-                </a:solidFill>
-              </a:rPr>
-              <a:t>Réglages choisis sur des mesures sans fenêtre, rejouables par graine</a:t>
-            </a:r>
-            <a:endParaRPr lang="en-US" sz="1600" dirty="0"/>
-          </a:p>
-        </p:txBody>
-      </p:sp>
-      <p:sp>
-        <p:nvSpPr>
-          <p:cNvPr id="10" name="Carte"/>
-          <p:cNvSpPr/>
-          <p:nvPr/>
-        </p:nvSpPr>
-        <p:spPr>
-          <a:xfrm>
-            <a:off x="3703320" y="4663440"/>
-            <a:ext cx="3977640" cy="1188720"/>
-          </a:xfrm>
-          <a:prstGeom prst="roundRect">
-            <a:avLst>
-              <a:gd name="adj" fmla="val 13846"/>
-            </a:avLst>
-          </a:prstGeom>
-          <a:solidFill>
-            <a:schemeClr val="bg2"/>
-          </a:solidFill>
-          <a:ln w="12700">
-            <a:solidFill>
-              <a:schemeClr val="bg2"/>
-            </a:solidFill>
-            <a:prstDash val="solid"/>
-          </a:ln>
-        </p:spPr>
-      </p:sp>
-      <p:sp>
-        <p:nvSpPr>
-          <p:cNvPr id="11" name="Text 8"/>
-          <p:cNvSpPr txBox="1"/>
-          <p:nvPr/>
-        </p:nvSpPr>
-        <p:spPr>
-          <a:xfrm>
-            <a:off x="3931920" y="4663440"/>
-            <a:ext cx="3520440" cy="1188720"/>
-          </a:xfrm>
-          <a:prstGeom prst="rect">
-            <a:avLst/>
-          </a:prstGeom>
-          <a:noFill/>
-          <a:ln/>
-        </p:spPr>
-        <p:txBody>
-          <a:bodyPr wrap="square" lIns="0" tIns="0" rIns="0" bIns="0" rtlCol="0" anchor="ctr"/>
-          <a:lstStyle/>
-          <a:p>
-            <a:pPr indent="0" marL="0">
-              <a:buNone/>
-            </a:pPr>
-            <a:r>
-              <a:rPr lang="en-US" sz="1600" dirty="0">
-                <a:solidFill>
-                  <a:schemeClr val="tx1"/>
-                </a:solidFill>
-              </a:rPr>
-              <a:t>Proche des boids de Reynolds : séparation, alignement, cohésion</a:t>
-            </a:r>
-            <a:endParaRPr lang="en-US" sz="1600" dirty="0"/>
-          </a:p>
-        </p:txBody>
-      </p:sp>
-      <p:sp>
-        <p:nvSpPr>
-          <p:cNvPr id="12" name="Pastille −"/>
-          <p:cNvSpPr/>
-          <p:nvPr/>
-        </p:nvSpPr>
-        <p:spPr>
-          <a:xfrm>
-            <a:off x="7863840" y="1005840"/>
-            <a:ext cx="640080" cy="640080"/>
-          </a:xfrm>
-          <a:prstGeom prst="ellipse">
-            <a:avLst/>
-          </a:prstGeom>
-          <a:solidFill>
-            <a:schemeClr val="accent4"/>
-          </a:solidFill>
-          <a:ln w="12700">
-            <a:solidFill>
-              <a:schemeClr val="accent4"/>
-            </a:solidFill>
-            <a:prstDash val="solid"/>
-          </a:ln>
-        </p:spPr>
-      </p:sp>
-      <p:sp>
-        <p:nvSpPr>
-          <p:cNvPr id="13" name="Text 10"/>
-          <p:cNvSpPr txBox="1"/>
-          <p:nvPr/>
-        </p:nvSpPr>
-        <p:spPr>
-          <a:xfrm>
-            <a:off x="7863840" y="1005840"/>
-            <a:ext cx="640080" cy="640080"/>
-          </a:xfrm>
-          <a:prstGeom prst="rect">
-            <a:avLst/>
-          </a:prstGeom>
-          <a:noFill/>
-          <a:ln/>
-        </p:spPr>
-        <p:txBody>
-          <a:bodyPr wrap="square" lIns="0" tIns="0" rIns="0" bIns="0" rtlCol="0" anchor="ctr"/>
-          <a:lstStyle/>
-          <a:p>
-            <a:pPr algn="ctr" indent="0" marL="0">
-              <a:buNone/>
-            </a:pPr>
-            <a:r>
-              <a:rPr lang="en-US" sz="2400" b="1" dirty="0">
-                <a:solidFill>
-                  <a:schemeClr val="bg1"/>
-                </a:solidFill>
-              </a:rPr>
-              <a:t>−</a:t>
-            </a:r>
-            <a:endParaRPr lang="en-US" sz="2400" dirty="0"/>
-          </a:p>
-        </p:txBody>
-      </p:sp>
-      <p:sp>
-        <p:nvSpPr>
-          <p:cNvPr id="14" name="Carte"/>
-          <p:cNvSpPr/>
-          <p:nvPr/>
-        </p:nvSpPr>
-        <p:spPr>
-          <a:xfrm>
-            <a:off x="7863840" y="1920240"/>
-            <a:ext cx="3977640" cy="1188720"/>
-          </a:xfrm>
-          <a:prstGeom prst="roundRect">
-            <a:avLst>
-              <a:gd name="adj" fmla="val 13846"/>
-            </a:avLst>
-          </a:prstGeom>
-          <a:solidFill>
-            <a:schemeClr val="bg2"/>
-          </a:solidFill>
-          <a:ln w="12700">
-            <a:solidFill>
-              <a:schemeClr val="bg2"/>
-            </a:solidFill>
-            <a:prstDash val="solid"/>
-          </a:ln>
-        </p:spPr>
-      </p:sp>
-      <p:sp>
-        <p:nvSpPr>
-          <p:cNvPr id="15" name="Text 12"/>
-          <p:cNvSpPr txBox="1"/>
-          <p:nvPr/>
-        </p:nvSpPr>
-        <p:spPr>
-          <a:xfrm>
-            <a:off x="8092440" y="1920240"/>
-            <a:ext cx="3520440" cy="1188720"/>
-          </a:xfrm>
-          <a:prstGeom prst="rect">
-            <a:avLst/>
-          </a:prstGeom>
-          <a:noFill/>
-          <a:ln/>
-        </p:spPr>
-        <p:txBody>
-          <a:bodyPr wrap="square" lIns="0" tIns="0" rIns="0" bIns="0" rtlCol="0" anchor="ctr"/>
-          <a:lstStyle/>
-          <a:p>
-            <a:pPr indent="0" marL="0">
-              <a:buNone/>
-            </a:pPr>
-            <a:r>
-              <a:rPr lang="en-US" sz="1600" dirty="0">
-                <a:solidFill>
-                  <a:schemeClr val="tx1"/>
-                </a:solidFill>
-              </a:rPr>
-              <a:t>Deux types d'agents seulement : le thon et le requin</a:t>
-            </a:r>
-            <a:endParaRPr lang="en-US" sz="1600" dirty="0"/>
-          </a:p>
-        </p:txBody>
-      </p:sp>
-      <p:sp>
-        <p:nvSpPr>
-          <p:cNvPr id="16" name="Carte"/>
-          <p:cNvSpPr/>
-          <p:nvPr/>
-        </p:nvSpPr>
-        <p:spPr>
-          <a:xfrm>
-            <a:off x="7863840" y="3291840"/>
-            <a:ext cx="3977640" cy="1188720"/>
-          </a:xfrm>
-          <a:prstGeom prst="roundRect">
-            <a:avLst>
-              <a:gd name="adj" fmla="val 13846"/>
-            </a:avLst>
-          </a:prstGeom>
-          <a:solidFill>
-            <a:schemeClr val="bg2"/>
-          </a:solidFill>
-          <a:ln w="12700">
-            <a:solidFill>
-              <a:schemeClr val="bg2"/>
-            </a:solidFill>
-            <a:prstDash val="solid"/>
-          </a:ln>
-        </p:spPr>
-      </p:sp>
-      <p:sp>
-        <p:nvSpPr>
-          <p:cNvPr id="17" name="Text 14"/>
-          <p:cNvSpPr txBox="1"/>
-          <p:nvPr/>
-        </p:nvSpPr>
-        <p:spPr>
-          <a:xfrm>
-            <a:off x="8092440" y="3291840"/>
-            <a:ext cx="3520440" cy="1188720"/>
-          </a:xfrm>
-          <a:prstGeom prst="rect">
-            <a:avLst/>
-          </a:prstGeom>
-          <a:noFill/>
-          <a:ln/>
-        </p:spPr>
-        <p:txBody>
-          <a:bodyPr wrap="square" lIns="0" tIns="0" rIns="0" bIns="0" rtlCol="0" anchor="ctr"/>
-          <a:lstStyle/>
-          <a:p>
-            <a:pPr indent="0" marL="0">
-              <a:buNone/>
-            </a:pPr>
-            <a:r>
-              <a:rPr lang="en-US" sz="1600" dirty="0">
-                <a:solidFill>
-                  <a:schemeClr val="tx1"/>
-                </a:solidFill>
-              </a:rPr>
-              <a:t>En fuyant le requin, des thons sortent parfois des parois</a:t>
-            </a:r>
-            <a:endParaRPr lang="en-US" sz="1600" dirty="0"/>
-          </a:p>
-        </p:txBody>
-      </p:sp>
-      <p:sp>
-        <p:nvSpPr>
-          <p:cNvPr id="18" name="Carte"/>
-          <p:cNvSpPr/>
-          <p:nvPr/>
-        </p:nvSpPr>
-        <p:spPr>
-          <a:xfrm>
-            <a:off x="7863840" y="4663440"/>
-            <a:ext cx="3977640" cy="1188720"/>
-          </a:xfrm>
-          <a:prstGeom prst="roundRect">
-            <a:avLst>
-              <a:gd name="adj" fmla="val 13846"/>
-            </a:avLst>
-          </a:prstGeom>
-          <a:solidFill>
-            <a:schemeClr val="bg2"/>
-          </a:solidFill>
-          <a:ln w="12700">
-            <a:solidFill>
-              <a:schemeClr val="bg2"/>
-            </a:solidFill>
-            <a:prstDash val="solid"/>
-          </a:ln>
-        </p:spPr>
-      </p:sp>
-      <p:sp>
-        <p:nvSpPr>
-          <p:cNvPr id="19" name="Text 16"/>
-          <p:cNvSpPr txBox="1"/>
-          <p:nvPr/>
-        </p:nvSpPr>
-        <p:spPr>
-          <a:xfrm>
-            <a:off x="8092440" y="4663440"/>
-            <a:ext cx="3520440" cy="1188720"/>
-          </a:xfrm>
-          <a:prstGeom prst="rect">
-            <a:avLst/>
-          </a:prstGeom>
-          <a:noFill/>
-          <a:ln/>
-        </p:spPr>
-        <p:txBody>
-          <a:bodyPr wrap="square" lIns="0" tIns="0" rIns="0" bIns="0" rtlCol="0" anchor="ctr"/>
-          <a:lstStyle/>
-          <a:p>
-            <a:pPr indent="0" marL="0">
-              <a:buNone/>
-            </a:pPr>
-            <a:r>
-              <a:rPr lang="en-US" sz="1600" dirty="0">
-                <a:solidFill>
-                  <a:schemeClr val="tx1"/>
-                </a:solidFill>
-              </a:rPr>
-              <a:t>Loin du réel : thons identiques, ni faim ni fatigue, le requin n'attrape jamais</a:t>
-            </a:r>
-            <a:endParaRPr lang="en-US" sz="1600" dirty="0"/>
-          </a:p>
-        </p:txBody>
-      </p:sp>
-      <p:sp>
-        <p:nvSpPr>
-          <p:cNvPr id="25" name="Slide Number Placeholder 0"/>
-          <p:cNvSpPr>
-            <a:spLocks noGrp="1"/>
-          </p:cNvSpPr>
-          <p:nvPr>
-            <p:ph type="sldNum" sz="quarter" idx="4294967295"/>
-          </p:nvPr>
-        </p:nvSpPr>
-        <p:spPr>
-          <a:xfrm>
-            <a:off x="411480" y="5760720"/>
-            <a:ext cx="1371600" cy="548640"/>
-          </a:xfrm>
-          <a:prstGeom prst="rect">
-            <a:avLst/>
-          </a:prstGeom>
-          <a:extLst>
-            <a:ext uri="{C572A759-6A51-4108-AA02-DFA0A04FC94B}">
-              <ma14:wrappingTextBoxFlag xmlns:ma14="http://schemas.microsoft.com/office/mac/drawingml/2011/main" val="0"/>
-            </a:ext>
-          </a:extLst>
-        </p:spPr>
-        <p:txBody>
-          <a:bodyPr/>
-          <a:lstStyle>
-            <a:lvl1pPr>
-              <a:defRPr sz="3200">
-                <a:solidFill>
-                  <a:schemeClr val="accent2"/>
-                </a:solidFill>
-              </a:defRPr>
-            </a:lvl1pPr>
-          </a:lstStyle>
-          <a:p>
-            <a:pPr algn="l"/>
-            <a:fld id="{F7021451-1387-4CA6-816F-3879F97B5CBC}" type="slidenum">
-              <a:rPr b="1" lang="en-US"/>
-              <a:t>9</a:t>
             </a:fld>
             <a:endParaRPr lang="en-US"/>
           </a:p>

</xml_diff>

<commit_message>
doc: ajoute la diapo « Les + et les − » avant les perspectives
Co-Authored-By: Claude Opus 5.5 <noreply@anthropic.com>
</commit_message>
<xml_diff>
--- a/soutenance/thon-sur-thon.pptx
+++ b/soutenance/thon-sur-thon.pptx
@@ -12,6 +12,7 @@
     <p:sldId id="260" r:id="rId6"/>
     <p:sldId id="261" r:id="rId7"/>
     <p:sldId id="262" r:id="rId8"/>
+    <p:sldId id="264" r:id="rId15"/>
     <p:sldId id="263" r:id="rId9"/>
   </p:sldIdLst>
   <p:notesMasterIdLst>
@@ -3304,6 +3305,614 @@
                 </a:solidFill>
               </a:rPr>
               <a:t>pour chercher les voisins plus vite, avec beaucoup de thons</a:t>
+            </a:r>
+            <a:endParaRPr lang="en-US" sz="1600" dirty="0"/>
+          </a:p>
+        </p:txBody>
+      </p:sp>
+      <p:sp>
+        <p:nvSpPr>
+          <p:cNvPr id="25" name="Slide Number Placeholder 0"/>
+          <p:cNvSpPr>
+            <a:spLocks noGrp="1"/>
+          </p:cNvSpPr>
+          <p:nvPr>
+            <p:ph type="sldNum" sz="quarter" idx="4294967295"/>
+          </p:nvPr>
+        </p:nvSpPr>
+        <p:spPr>
+          <a:xfrm>
+            <a:off x="411480" y="5760720"/>
+            <a:ext cx="1371600" cy="548640"/>
+          </a:xfrm>
+          <a:prstGeom prst="rect">
+            <a:avLst/>
+          </a:prstGeom>
+          <a:extLst>
+            <a:ext uri="{C572A759-6A51-4108-AA02-DFA0A04FC94B}">
+              <ma14:wrappingTextBoxFlag xmlns:ma14="http://schemas.microsoft.com/office/mac/drawingml/2011/main" val="0"/>
+            </a:ext>
+          </a:extLst>
+        </p:spPr>
+        <p:txBody>
+          <a:bodyPr/>
+          <a:lstStyle>
+            <a:lvl1pPr>
+              <a:defRPr sz="3200">
+                <a:solidFill>
+                  <a:schemeClr val="accent2"/>
+                </a:solidFill>
+              </a:defRPr>
+            </a:lvl1pPr>
+          </a:lstStyle>
+          <a:p>
+            <a:pPr algn="l"/>
+            <a:fld id="{F7021451-1387-4CA6-816F-3879F97B5CBC}" type="slidenum">
+              <a:rPr b="1" lang="en-US"/>
+              <a:t>9</a:t>
+            </a:fld>
+            <a:endParaRPr lang="en-US"/>
+          </a:p>
+        </p:txBody>
+      </p:sp>
+    </p:spTree>
+  </p:cSld>
+  <p:clrMapOvr>
+    <a:masterClrMapping/>
+  </p:clrMapOvr>
+</p:sld>
+</file>
+
+<file path=ppt/slides/slide9.xml><?xml version="1.0" encoding="utf-8"?>
+<p:sld xmlns:a="http://schemas.openxmlformats.org/drawingml/2006/main" xmlns:r="http://schemas.openxmlformats.org/officeDocument/2006/relationships" xmlns:p="http://schemas.openxmlformats.org/presentationml/2006/main">
+  <p:cSld name="Slide 9">
+    <p:spTree>
+      <p:nvGrpSpPr>
+        <p:cNvPr id="1" name=""/>
+        <p:cNvGrpSpPr/>
+        <p:nvPr/>
+      </p:nvGrpSpPr>
+      <p:grpSpPr>
+        <a:xfrm>
+          <a:off x="0" y="0"/>
+          <a:ext cx="0" cy="0"/>
+          <a:chOff x="0" y="0"/>
+          <a:chExt cx="0" cy="0"/>
+        </a:xfrm>
+      </p:grpSpPr>
+      <p:sp>
+        <p:nvSpPr>
+          <p:cNvPr id="2" name="Text 2"/>
+          <p:cNvSpPr/>
+          <p:nvPr>
+            <p:ph idx="102" type="title" hasCustomPrompt="1"/>
+          </p:nvPr>
+        </p:nvSpPr>
+        <p:spPr>
+          <a:xfrm>
+            <a:off x="411480" y="548640"/>
+            <a:ext cx="2560320" cy="4114800"/>
+          </a:xfrm>
+          <a:prstGeom prst="rect">
+            <a:avLst/>
+          </a:prstGeom>
+          <a:noFill/>
+          <a:ln/>
+        </p:spPr>
+        <p:txBody>
+          <a:bodyPr wrap="square" lIns="0" tIns="0" rIns="0" bIns="0" rtlCol="0" anchor="t"/>
+          <a:lstStyle/>
+          <a:p>
+            <a:pPr algn="l" indent="0" marL="0">
+              <a:buNone/>
+            </a:pPr>
+            <a:r>
+              <a:rPr lang="en-US" sz="2600" b="1" dirty="0">
+                <a:solidFill>
+                  <a:schemeClr val="bg1"/>
+                </a:solidFill>
+              </a:rPr>
+              <a:t>Les + et les −</a:t>
+            </a:r>
+            <a:endParaRPr lang="en-US" sz="2600" dirty="0"/>
+          </a:p>
+        </p:txBody>
+      </p:sp>
+      <p:sp>
+        <p:nvSpPr>
+          <p:cNvPr id="4" name="Pastille +"/>
+          <p:cNvSpPr/>
+          <p:nvPr/>
+        </p:nvSpPr>
+        <p:spPr>
+          <a:xfrm>
+            <a:off x="3703320" y="1005840"/>
+            <a:ext cx="640080" cy="640080"/>
+          </a:xfrm>
+          <a:prstGeom prst="ellipse">
+            <a:avLst/>
+          </a:prstGeom>
+          <a:solidFill>
+            <a:schemeClr val="accent5"/>
+          </a:solidFill>
+          <a:ln w="12700">
+            <a:solidFill>
+              <a:schemeClr val="accent5"/>
+            </a:solidFill>
+            <a:prstDash val="solid"/>
+          </a:ln>
+        </p:spPr>
+      </p:sp>
+      <p:sp>
+        <p:nvSpPr>
+          <p:cNvPr id="5" name="Text 2"/>
+          <p:cNvSpPr txBox="1"/>
+          <p:nvPr/>
+        </p:nvSpPr>
+        <p:spPr>
+          <a:xfrm>
+            <a:off x="3703320" y="1005840"/>
+            <a:ext cx="640080" cy="640080"/>
+          </a:xfrm>
+          <a:prstGeom prst="rect">
+            <a:avLst/>
+          </a:prstGeom>
+          <a:noFill/>
+          <a:ln/>
+        </p:spPr>
+        <p:txBody>
+          <a:bodyPr wrap="square" lIns="0" tIns="0" rIns="0" bIns="0" rtlCol="0" anchor="ctr"/>
+          <a:lstStyle/>
+          <a:p>
+            <a:pPr algn="ctr" indent="0" marL="0">
+              <a:buNone/>
+            </a:pPr>
+            <a:r>
+              <a:rPr lang="en-US" sz="2400" b="1" dirty="0">
+                <a:solidFill>
+                  <a:schemeClr val="bg1"/>
+                </a:solidFill>
+              </a:rPr>
+              <a:t>+</a:t>
+            </a:r>
+            <a:endParaRPr lang="en-US" sz="2400" dirty="0"/>
+          </a:p>
+        </p:txBody>
+      </p:sp>
+      <p:sp>
+        <p:nvSpPr>
+          <p:cNvPr id="6" name="Carte"/>
+          <p:cNvSpPr/>
+          <p:nvPr/>
+        </p:nvSpPr>
+        <p:spPr>
+          <a:xfrm>
+            <a:off x="3703320" y="1920240"/>
+            <a:ext cx="3977640" cy="1188720"/>
+          </a:xfrm>
+          <a:prstGeom prst="roundRect">
+            <a:avLst>
+              <a:gd name="adj" fmla="val 13846"/>
+            </a:avLst>
+          </a:prstGeom>
+          <a:solidFill>
+            <a:schemeClr val="bg2"/>
+          </a:solidFill>
+          <a:ln w="12700">
+            <a:solidFill>
+              <a:schemeClr val="bg2"/>
+            </a:solidFill>
+            <a:prstDash val="solid"/>
+          </a:ln>
+        </p:spPr>
+      </p:sp>
+      <p:sp>
+        <p:nvSpPr>
+          <p:cNvPr id="7" name="Text 4"/>
+          <p:cNvSpPr txBox="1"/>
+          <p:nvPr/>
+        </p:nvSpPr>
+        <p:spPr>
+          <a:xfrm>
+            <a:off x="3931920" y="1920240"/>
+            <a:ext cx="3520440" cy="1188720"/>
+          </a:xfrm>
+          <a:prstGeom prst="rect">
+            <a:avLst/>
+          </a:prstGeom>
+          <a:noFill/>
+          <a:ln/>
+        </p:spPr>
+        <p:txBody>
+          <a:bodyPr wrap="square" lIns="0" tIns="0" rIns="0" bIns="0" rtlCol="0" anchor="ctr"/>
+          <a:lstStyle/>
+          <a:p>
+            <a:pPr indent="0" marL="0">
+              <a:buNone/>
+            </a:pPr>
+            <a:r>
+              <a:rPr lang="en-US" sz="1600" dirty="0">
+                <a:solidFill>
+                  <a:schemeClr val="tx1"/>
+                </a:solidFill>
+              </a:rPr>
+              <a:t>Un banc sans chef : chaque thon ne regarde que ses voisins.</a:t>
+            </a:r>
+            <a:endParaRPr lang="en-US" sz="1600" dirty="0"/>
+          </a:p>
+        </p:txBody>
+      </p:sp>
+      <p:sp>
+        <p:nvSpPr>
+          <p:cNvPr id="8" name="Carte"/>
+          <p:cNvSpPr/>
+          <p:nvPr/>
+        </p:nvSpPr>
+        <p:spPr>
+          <a:xfrm>
+            <a:off x="3703320" y="3291840"/>
+            <a:ext cx="3977640" cy="1188720"/>
+          </a:xfrm>
+          <a:prstGeom prst="roundRect">
+            <a:avLst>
+              <a:gd name="adj" fmla="val 13846"/>
+            </a:avLst>
+          </a:prstGeom>
+          <a:solidFill>
+            <a:schemeClr val="bg2"/>
+          </a:solidFill>
+          <a:ln w="12700">
+            <a:solidFill>
+              <a:schemeClr val="bg2"/>
+            </a:solidFill>
+            <a:prstDash val="solid"/>
+          </a:ln>
+        </p:spPr>
+      </p:sp>
+      <p:sp>
+        <p:nvSpPr>
+          <p:cNvPr id="9" name="Text 6"/>
+          <p:cNvSpPr txBox="1"/>
+          <p:nvPr/>
+        </p:nvSpPr>
+        <p:spPr>
+          <a:xfrm>
+            <a:off x="3931920" y="3291840"/>
+            <a:ext cx="3520440" cy="1188720"/>
+          </a:xfrm>
+          <a:prstGeom prst="rect">
+            <a:avLst/>
+          </a:prstGeom>
+          <a:noFill/>
+          <a:ln/>
+        </p:spPr>
+        <p:txBody>
+          <a:bodyPr wrap="square" lIns="0" tIns="0" rIns="0" bIns="0" rtlCol="0" anchor="ctr"/>
+          <a:lstStyle/>
+          <a:p>
+            <a:pPr indent="0" marL="0">
+              <a:buNone/>
+            </a:pPr>
+            <a:r>
+              <a:rPr lang="en-US" sz="1600" dirty="0">
+                <a:solidFill>
+                  <a:schemeClr val="tx1"/>
+                </a:solidFill>
+              </a:rPr>
+              <a:t>Le banc se coupe puis se ressoude tout seul, devant le rocher comme devant le requin.</a:t>
+            </a:r>
+            <a:endParaRPr lang="en-US" sz="1600" dirty="0"/>
+          </a:p>
+        </p:txBody>
+      </p:sp>
+      <p:sp>
+        <p:nvSpPr>
+          <p:cNvPr id="10" name="Carte"/>
+          <p:cNvSpPr/>
+          <p:nvPr/>
+        </p:nvSpPr>
+        <p:spPr>
+          <a:xfrm>
+            <a:off x="3703320" y="4663440"/>
+            <a:ext cx="3977640" cy="1188720"/>
+          </a:xfrm>
+          <a:prstGeom prst="roundRect">
+            <a:avLst>
+              <a:gd name="adj" fmla="val 13846"/>
+            </a:avLst>
+          </a:prstGeom>
+          <a:solidFill>
+            <a:schemeClr val="bg2"/>
+          </a:solidFill>
+          <a:ln w="12700">
+            <a:solidFill>
+              <a:schemeClr val="bg2"/>
+            </a:solidFill>
+            <a:prstDash val="solid"/>
+          </a:ln>
+        </p:spPr>
+      </p:sp>
+      <p:sp>
+        <p:nvSpPr>
+          <p:cNvPr id="11" name="Text 8"/>
+          <p:cNvSpPr txBox="1"/>
+          <p:nvPr/>
+        </p:nvSpPr>
+        <p:spPr>
+          <a:xfrm>
+            <a:off x="3931920" y="4663440"/>
+            <a:ext cx="3520440" cy="1188720"/>
+          </a:xfrm>
+          <a:prstGeom prst="rect">
+            <a:avLst/>
+          </a:prstGeom>
+          <a:noFill/>
+          <a:ln/>
+        </p:spPr>
+        <p:txBody>
+          <a:bodyPr wrap="square" lIns="0" tIns="0" rIns="0" bIns="0" rtlCol="0" anchor="ctr"/>
+          <a:lstStyle/>
+          <a:p>
+            <a:pPr indent="0" marL="0">
+              <a:buNone/>
+            </a:pPr>
+            <a:r>
+              <a:rPr lang="en-US" sz="1600" dirty="0">
+                <a:solidFill>
+                  <a:schemeClr val="tx1"/>
+                </a:solidFill>
+              </a:rPr>
+              <a:t>Peu de règles, un comportement riche : sept forces suffisent au thon.</a:t>
+            </a:r>
+            <a:endParaRPr lang="en-US" sz="1600" dirty="0"/>
+          </a:p>
+        </p:txBody>
+      </p:sp>
+      <p:sp>
+        <p:nvSpPr>
+          <p:cNvPr id="12" name="Pastille −"/>
+          <p:cNvSpPr/>
+          <p:nvPr/>
+        </p:nvSpPr>
+        <p:spPr>
+          <a:xfrm>
+            <a:off x="7863840" y="1005840"/>
+            <a:ext cx="640080" cy="640080"/>
+          </a:xfrm>
+          <a:prstGeom prst="ellipse">
+            <a:avLst/>
+          </a:prstGeom>
+          <a:solidFill>
+            <a:schemeClr val="accent4"/>
+          </a:solidFill>
+          <a:ln w="12700">
+            <a:solidFill>
+              <a:schemeClr val="accent4"/>
+            </a:solidFill>
+            <a:prstDash val="solid"/>
+          </a:ln>
+        </p:spPr>
+      </p:sp>
+      <p:sp>
+        <p:nvSpPr>
+          <p:cNvPr id="13" name="Text 10"/>
+          <p:cNvSpPr txBox="1"/>
+          <p:nvPr/>
+        </p:nvSpPr>
+        <p:spPr>
+          <a:xfrm>
+            <a:off x="7863840" y="1005840"/>
+            <a:ext cx="640080" cy="640080"/>
+          </a:xfrm>
+          <a:prstGeom prst="rect">
+            <a:avLst/>
+          </a:prstGeom>
+          <a:noFill/>
+          <a:ln/>
+        </p:spPr>
+        <p:txBody>
+          <a:bodyPr wrap="square" lIns="0" tIns="0" rIns="0" bIns="0" rtlCol="0" anchor="ctr"/>
+          <a:lstStyle/>
+          <a:p>
+            <a:pPr algn="ctr" indent="0" marL="0">
+              <a:buNone/>
+            </a:pPr>
+            <a:r>
+              <a:rPr lang="en-US" sz="2400" b="1" dirty="0">
+                <a:solidFill>
+                  <a:schemeClr val="bg1"/>
+                </a:solidFill>
+              </a:rPr>
+              <a:t>−</a:t>
+            </a:r>
+            <a:endParaRPr lang="en-US" sz="2400" dirty="0"/>
+          </a:p>
+        </p:txBody>
+      </p:sp>
+      <p:sp>
+        <p:nvSpPr>
+          <p:cNvPr id="14" name="Carte"/>
+          <p:cNvSpPr/>
+          <p:nvPr/>
+        </p:nvSpPr>
+        <p:spPr>
+          <a:xfrm>
+            <a:off x="7863840" y="1920240"/>
+            <a:ext cx="3977640" cy="1188720"/>
+          </a:xfrm>
+          <a:prstGeom prst="roundRect">
+            <a:avLst>
+              <a:gd name="adj" fmla="val 13846"/>
+            </a:avLst>
+          </a:prstGeom>
+          <a:solidFill>
+            <a:schemeClr val="bg2"/>
+          </a:solidFill>
+          <a:ln w="12700">
+            <a:solidFill>
+              <a:schemeClr val="bg2"/>
+            </a:solidFill>
+            <a:prstDash val="solid"/>
+          </a:ln>
+        </p:spPr>
+      </p:sp>
+      <p:sp>
+        <p:nvSpPr>
+          <p:cNvPr id="15" name="Text 12"/>
+          <p:cNvSpPr txBox="1"/>
+          <p:nvPr/>
+        </p:nvSpPr>
+        <p:spPr>
+          <a:xfrm>
+            <a:off x="8092440" y="1920240"/>
+            <a:ext cx="3520440" cy="1188720"/>
+          </a:xfrm>
+          <a:prstGeom prst="rect">
+            <a:avLst/>
+          </a:prstGeom>
+          <a:noFill/>
+          <a:ln/>
+        </p:spPr>
+        <p:txBody>
+          <a:bodyPr wrap="square" lIns="0" tIns="0" rIns="0" bIns="0" rtlCol="0" anchor="ctr"/>
+          <a:lstStyle/>
+          <a:p>
+            <a:pPr indent="0" marL="0">
+              <a:buNone/>
+            </a:pPr>
+            <a:r>
+              <a:rPr lang="en-US" sz="1600" dirty="0">
+                <a:solidFill>
+                  <a:schemeClr val="tx1"/>
+                </a:solidFill>
+              </a:rPr>
+              <a:t>Deux types d'agents seulement : le thon et le requin.</a:t>
+            </a:r>
+            <a:endParaRPr lang="en-US" sz="1600" dirty="0"/>
+          </a:p>
+        </p:txBody>
+      </p:sp>
+      <p:sp>
+        <p:nvSpPr>
+          <p:cNvPr id="16" name="Carte"/>
+          <p:cNvSpPr/>
+          <p:nvPr/>
+        </p:nvSpPr>
+        <p:spPr>
+          <a:xfrm>
+            <a:off x="7863840" y="3291840"/>
+            <a:ext cx="3977640" cy="1188720"/>
+          </a:xfrm>
+          <a:prstGeom prst="roundRect">
+            <a:avLst>
+              <a:gd name="adj" fmla="val 13846"/>
+            </a:avLst>
+          </a:prstGeom>
+          <a:solidFill>
+            <a:schemeClr val="bg2"/>
+          </a:solidFill>
+          <a:ln w="12700">
+            <a:solidFill>
+              <a:schemeClr val="bg2"/>
+            </a:solidFill>
+            <a:prstDash val="solid"/>
+          </a:ln>
+        </p:spPr>
+      </p:sp>
+      <p:sp>
+        <p:nvSpPr>
+          <p:cNvPr id="17" name="Text 14"/>
+          <p:cNvSpPr txBox="1"/>
+          <p:nvPr/>
+        </p:nvSpPr>
+        <p:spPr>
+          <a:xfrm>
+            <a:off x="8092440" y="3291840"/>
+            <a:ext cx="3520440" cy="1188720"/>
+          </a:xfrm>
+          <a:prstGeom prst="rect">
+            <a:avLst/>
+          </a:prstGeom>
+          <a:noFill/>
+          <a:ln/>
+        </p:spPr>
+        <p:txBody>
+          <a:bodyPr wrap="square" lIns="0" tIns="0" rIns="0" bIns="0" rtlCol="0" anchor="ctr"/>
+          <a:lstStyle/>
+          <a:p>
+            <a:pPr indent="0" marL="0">
+              <a:buNone/>
+            </a:pPr>
+            <a:r>
+              <a:rPr lang="en-US" sz="1600" dirty="0">
+                <a:solidFill>
+                  <a:schemeClr val="tx1"/>
+                </a:solidFill>
+              </a:rPr>
+              <a:t>En fuyant le requin, des thons sortent parfois des parois.</a:t>
+            </a:r>
+            <a:endParaRPr lang="en-US" sz="1600" dirty="0"/>
+          </a:p>
+        </p:txBody>
+      </p:sp>
+      <p:sp>
+        <p:nvSpPr>
+          <p:cNvPr id="18" name="Carte"/>
+          <p:cNvSpPr/>
+          <p:nvPr/>
+        </p:nvSpPr>
+        <p:spPr>
+          <a:xfrm>
+            <a:off x="7863840" y="4663440"/>
+            <a:ext cx="3977640" cy="1188720"/>
+          </a:xfrm>
+          <a:prstGeom prst="roundRect">
+            <a:avLst>
+              <a:gd name="adj" fmla="val 13846"/>
+            </a:avLst>
+          </a:prstGeom>
+          <a:solidFill>
+            <a:schemeClr val="bg2"/>
+          </a:solidFill>
+          <a:ln w="12700">
+            <a:solidFill>
+              <a:schemeClr val="bg2"/>
+            </a:solidFill>
+            <a:prstDash val="solid"/>
+          </a:ln>
+        </p:spPr>
+      </p:sp>
+      <p:sp>
+        <p:nvSpPr>
+          <p:cNvPr id="19" name="Text 16"/>
+          <p:cNvSpPr txBox="1"/>
+          <p:nvPr/>
+        </p:nvSpPr>
+        <p:spPr>
+          <a:xfrm>
+            <a:off x="8092440" y="4663440"/>
+            <a:ext cx="3520440" cy="1188720"/>
+          </a:xfrm>
+          <a:prstGeom prst="rect">
+            <a:avLst/>
+          </a:prstGeom>
+          <a:noFill/>
+          <a:ln/>
+        </p:spPr>
+        <p:txBody>
+          <a:bodyPr wrap="square" lIns="0" tIns="0" rIns="0" bIns="0" rtlCol="0" anchor="ctr"/>
+          <a:lstStyle/>
+          <a:p>
+            <a:pPr indent="0" marL="0">
+              <a:buNone/>
+            </a:pPr>
+            <a:r>
+              <a:rPr lang="en-US" sz="1600" dirty="0">
+                <a:solidFill>
+                  <a:schemeClr val="tx1"/>
+                </a:solidFill>
+              </a:rPr>
+              <a:t>Loin du réel : ni faim ni fatigue, le requin n'attrape jamais.</a:t>
             </a:r>
             <a:endParaRPr lang="en-US" sz="1600" dirty="0"/>
           </a:p>

</xml_diff>

<commit_message>
doc: remplace la grille spatiale par « Trouver un emploi » au diaporama
Co-Authored-By: Claude Opus 5.5 <noreply@anthropic.com>
</commit_message>
<xml_diff>
--- a/soutenance/thon-sur-thon.pptx
+++ b/soutenance/thon-sur-thon.pptx
@@ -3268,7 +3268,7 @@
                   <a:schemeClr val="accent2"/>
                 </a:solidFill>
               </a:rPr>
-              <a:t>Une grille spatiale</a:t>
+              <a:t>Trouver un emploi</a:t>
             </a:r>
             <a:endParaRPr lang="en-US" sz="2200" dirty="0"/>
           </a:p>
@@ -3304,7 +3304,7 @@
                   <a:schemeClr val="bg1"/>
                 </a:solidFill>
               </a:rPr>
-              <a:t>pour chercher les voisins plus vite, avec beaucoup de thons</a:t>
+              <a:t/>
             </a:r>
             <a:endParaRPr lang="en-US" sz="1600" dirty="0"/>
           </a:p>

</xml_diff>